<commit_message>
chore(pptx): update demo slide
</commit_message>
<xml_diff>
--- a/apps/docs/public/assets/after-the-needle-drops-mat.pptx
+++ b/apps/docs/public/assets/after-the-needle-drops-mat.pptx
@@ -1,137 +1,42 @@
 
 <file path=ppt/presentation.xml><?xml version="1.0" encoding="utf-8"?>
-<p:presentation xmlns:r="http://schemas.openxmlformats.org/officeDocument/2006/relationships" xmlns:p="http://schemas.openxmlformats.org/presentationml/2006/main" saveSubsetFonts="false" embedTrueTypeFonts="true">
+<p:presentation xmlns:p="http://schemas.openxmlformats.org/presentationml/2006/main" embedTrueTypeFonts="1" saveSubsetFonts="0">
   <p:sldMasterIdLst>
-    <p:sldMasterId xmlns:r="http://schemas.openxmlformats.org/officeDocument/2006/relationships" id="2147483648" r:id="R0cd65d591a6a48af"/>
+    <p:sldMasterId xmlns:r="http://schemas.openxmlformats.org/officeDocument/2006/relationships" id="2147483648" r:id="R985fffaa8ecf4e64"/>
   </p:sldMasterIdLst>
   <p:notesMasterIdLst>
-    <p:notesMasterId xmlns:r="http://schemas.openxmlformats.org/officeDocument/2006/relationships" r:id="Rdeb84743a7c14ac1"/>
+    <p:notesMasterId xmlns:r="http://schemas.openxmlformats.org/officeDocument/2006/relationships" r:id="Rf0b747b4d25348b3"/>
   </p:notesMasterIdLst>
   <p:sldIdLst>
-    <p:sldId xmlns:r="http://schemas.openxmlformats.org/officeDocument/2006/relationships" id="256" r:id="R38cf979c59fc486c"/>
-    <p:sldId xmlns:r="http://schemas.openxmlformats.org/officeDocument/2006/relationships" id="257" r:id="Ra9bd7656bfb248b6"/>
-    <p:sldId xmlns:r="http://schemas.openxmlformats.org/officeDocument/2006/relationships" id="258" r:id="R7018436128384cc3"/>
-    <p:sldId xmlns:r="http://schemas.openxmlformats.org/officeDocument/2006/relationships" id="259" r:id="Ra2622099ae7c4920"/>
-    <p:sldId xmlns:r="http://schemas.openxmlformats.org/officeDocument/2006/relationships" id="260" r:id="R4bcd86a7e9804207"/>
-    <p:sldId xmlns:r="http://schemas.openxmlformats.org/officeDocument/2006/relationships" id="261" r:id="R3b753bd8b7fd4b4e"/>
-    <p:sldId xmlns:r="http://schemas.openxmlformats.org/officeDocument/2006/relationships" id="262" r:id="R53d0c15f54434ccb"/>
-    <p:sldId xmlns:r="http://schemas.openxmlformats.org/officeDocument/2006/relationships" id="263" r:id="R4ac4c32fe08748a9"/>
+    <p:sldId xmlns:r="http://schemas.openxmlformats.org/officeDocument/2006/relationships" id="256" r:id="Radc888fd38d04a0c"/>
+    <p:sldId xmlns:r="http://schemas.openxmlformats.org/officeDocument/2006/relationships" id="257" r:id="Rf529acfa66c94849"/>
+    <p:sldId xmlns:r="http://schemas.openxmlformats.org/officeDocument/2006/relationships" id="258" r:id="R30850e12c9b54e67"/>
+    <p:sldId xmlns:r="http://schemas.openxmlformats.org/officeDocument/2006/relationships" id="259" r:id="R44736552453f444e"/>
+    <p:sldId xmlns:r="http://schemas.openxmlformats.org/officeDocument/2006/relationships" id="260" r:id="Rf7a10974ad6a46b1"/>
+    <p:sldId xmlns:r="http://schemas.openxmlformats.org/officeDocument/2006/relationships" id="261" r:id="Rd0a0af7e0af04493"/>
+    <p:sldId xmlns:r="http://schemas.openxmlformats.org/officeDocument/2006/relationships" id="262" r:id="Rda21e34d44714bbf"/>
+    <p:sldId xmlns:r="http://schemas.openxmlformats.org/officeDocument/2006/relationships" id="263" r:id="Rb45fb6cc69704596"/>
   </p:sldIdLst>
   <p:sldSz cx="12192000" cy="6858000"/>
   <p:notesSz cx="6858000" cy="9144000"/>
   <p:embeddedFontLst>
     <p:embeddedFont>
       <p:font typeface="Bricolage Grotesque Display"/>
-      <p:regular r:id="rId201314"/>
+      <p:regular xmlns:r="http://schemas.openxmlformats.org/officeDocument/2006/relationships" r:id="Ra3888ce39a4c480c"/>
     </p:embeddedFont>
     <p:embeddedFont>
       <p:font typeface="Bricolage Grotesque Heading"/>
-      <p:regular r:id="rId201315"/>
+      <p:regular xmlns:r="http://schemas.openxmlformats.org/officeDocument/2006/relationships" r:id="R09480e41c8d248b8"/>
     </p:embeddedFont>
     <p:embeddedFont>
       <p:font typeface="DM Sans Text"/>
-      <p:regular r:id="rId201316"/>
+      <p:regular xmlns:r="http://schemas.openxmlformats.org/officeDocument/2006/relationships" r:id="R2fcbe9ac7db743ec"/>
     </p:embeddedFont>
     <p:embeddedFont>
       <p:font typeface="DM Mono Labels"/>
-      <p:regular r:id="rId201317"/>
+      <p:regular xmlns:r="http://schemas.openxmlformats.org/officeDocument/2006/relationships" r:id="R26c7882d1aca4fe0"/>
     </p:embeddedFont>
   </p:embeddedFontLst>
-  <p:defaultTextStyle>
-    <a:defPPr xmlns:a="http://schemas.openxmlformats.org/drawingml/2006/main">
-      <a:defRPr lang="en-US"/>
-    </a:defPPr>
-    <a:lvl1pPr xmlns:a="http://schemas.openxmlformats.org/drawingml/2006/main" marL="0" indent="0" algn="l" defTabSz="914400">
-      <a:defRPr sz="1800" kern="1200">
-        <a:solidFill>
-          <a:schemeClr val="tx1"/>
-        </a:solidFill>
-        <a:latin typeface="+mn-lt"/>
-        <a:ea typeface="+mn-ea"/>
-        <a:cs typeface="+mn-cs"/>
-      </a:defRPr>
-    </a:lvl1pPr>
-    <a:lvl2pPr xmlns:a="http://schemas.openxmlformats.org/drawingml/2006/main" marL="457200" indent="0" algn="l" defTabSz="914400">
-      <a:defRPr sz="1800" kern="1200">
-        <a:solidFill>
-          <a:schemeClr val="tx1"/>
-        </a:solidFill>
-        <a:latin typeface="+mn-lt"/>
-        <a:ea typeface="+mn-ea"/>
-        <a:cs typeface="+mn-cs"/>
-      </a:defRPr>
-    </a:lvl2pPr>
-    <a:lvl3pPr xmlns:a="http://schemas.openxmlformats.org/drawingml/2006/main" marL="914400" indent="0" algn="l" defTabSz="914400">
-      <a:defRPr sz="1800" kern="1200">
-        <a:solidFill>
-          <a:schemeClr val="tx1"/>
-        </a:solidFill>
-        <a:latin typeface="+mn-lt"/>
-        <a:ea typeface="+mn-ea"/>
-        <a:cs typeface="+mn-cs"/>
-      </a:defRPr>
-    </a:lvl3pPr>
-    <a:lvl4pPr xmlns:a="http://schemas.openxmlformats.org/drawingml/2006/main" marL="1371600" indent="0" algn="l" defTabSz="914400">
-      <a:defRPr sz="1800" kern="1200">
-        <a:solidFill>
-          <a:schemeClr val="tx1"/>
-        </a:solidFill>
-        <a:latin typeface="+mn-lt"/>
-        <a:ea typeface="+mn-ea"/>
-        <a:cs typeface="+mn-cs"/>
-      </a:defRPr>
-    </a:lvl4pPr>
-    <a:lvl5pPr xmlns:a="http://schemas.openxmlformats.org/drawingml/2006/main" marL="1828800" indent="0" algn="l" defTabSz="914400">
-      <a:defRPr sz="1800" kern="1200">
-        <a:solidFill>
-          <a:schemeClr val="tx1"/>
-        </a:solidFill>
-        <a:latin typeface="+mn-lt"/>
-        <a:ea typeface="+mn-ea"/>
-        <a:cs typeface="+mn-cs"/>
-      </a:defRPr>
-    </a:lvl5pPr>
-    <a:lvl6pPr xmlns:a="http://schemas.openxmlformats.org/drawingml/2006/main" marL="2286000" indent="0" algn="l" defTabSz="914400">
-      <a:defRPr sz="1800" kern="1200">
-        <a:solidFill>
-          <a:schemeClr val="tx1"/>
-        </a:solidFill>
-        <a:latin typeface="+mn-lt"/>
-        <a:ea typeface="+mn-ea"/>
-        <a:cs typeface="+mn-cs"/>
-      </a:defRPr>
-    </a:lvl6pPr>
-    <a:lvl7pPr xmlns:a="http://schemas.openxmlformats.org/drawingml/2006/main" marL="2743200" indent="0" algn="l" defTabSz="914400">
-      <a:defRPr sz="1800" kern="1200">
-        <a:solidFill>
-          <a:schemeClr val="tx1"/>
-        </a:solidFill>
-        <a:latin typeface="+mn-lt"/>
-        <a:ea typeface="+mn-ea"/>
-        <a:cs typeface="+mn-cs"/>
-      </a:defRPr>
-    </a:lvl7pPr>
-    <a:lvl8pPr xmlns:a="http://schemas.openxmlformats.org/drawingml/2006/main" marL="3200400" indent="0" algn="l" defTabSz="914400">
-      <a:defRPr sz="1800" kern="1200">
-        <a:solidFill>
-          <a:schemeClr val="tx1"/>
-        </a:solidFill>
-        <a:latin typeface="+mn-lt"/>
-        <a:ea typeface="+mn-ea"/>
-        <a:cs typeface="+mn-cs"/>
-      </a:defRPr>
-    </a:lvl8pPr>
-    <a:lvl9pPr xmlns:a="http://schemas.openxmlformats.org/drawingml/2006/main" marL="3657600" indent="0" algn="l" defTabSz="914400">
-      <a:defRPr sz="1800" kern="1200">
-        <a:solidFill>
-          <a:schemeClr val="tx1"/>
-        </a:solidFill>
-        <a:latin typeface="+mn-lt"/>
-        <a:ea typeface="+mn-ea"/>
-        <a:cs typeface="+mn-cs"/>
-      </a:defRPr>
-    </a:lvl9pPr>
-  </p:defaultTextStyle>
 </p:presentation>
 </file>
 
@@ -1360,7 +1265,7 @@
   </p:cSld>
   <p:clrMap bg1="lt1" tx1="dk1" bg2="lt2" tx2="dk2" accent1="accent1" accent2="accent2" accent3="accent3" accent4="accent4" accent5="accent5" accent6="accent6" hlink="hlink" folHlink="folHlink"/>
   <p:sldLayoutIdLst>
-    <p:sldLayoutId xmlns:r="http://schemas.openxmlformats.org/officeDocument/2006/relationships" id="2147483649" r:id="R35e67c870b2d48d1"/>
+    <p:sldLayoutId xmlns:r="http://schemas.openxmlformats.org/officeDocument/2006/relationships" id="2147483649" r:id="Rbd4c7f0909004e78"/>
   </p:sldLayoutIdLst>
   <p:txStyles>
     <p:titleStyle>
@@ -1894,6 +1799,7 @@
     <c:plotArea>
       <c:lineChart>
         <c:grouping val="standard"/>
+        <c:varyColors val="0"/>
         <c:ser>
           <c:idx val="0"/>
           <c:order val="0"/>
@@ -2051,6 +1957,9 @@
                         <a:alpha val="72000"/>
                       </a:srgbClr>
                     </a:solidFill>
+                    <a:latin typeface="DM Mono Labels"/>
+                    <a:ea typeface="DM Mono Labels"/>
+                    <a:cs typeface="DM Mono Labels"/>
                   </a:rPr>
                   <a:t>OCTAVE BAND · HZ</a:t>
                 </a:r>
@@ -2063,12 +1972,14 @@
             <a:p xmlns:a="http://schemas.openxmlformats.org/drawingml/2006/main">
               <a:pPr>
                 <a:defRPr sz="1275" b="1">
-                  <a:latin typeface="DM Mono Labels"/>
                   <a:solidFill>
                     <a:srgbClr val="F0E8D2">
                       <a:alpha val="72000"/>
                     </a:srgbClr>
                   </a:solidFill>
+                  <a:latin typeface="DM Mono Labels"/>
+                  <a:ea typeface="DM Mono Labels"/>
+                  <a:cs typeface="DM Mono Labels"/>
                 </a:defRPr>
               </a:pPr>
             </a:p>
@@ -2093,18 +2004,18 @@
           <a:p xmlns:a="http://schemas.openxmlformats.org/drawingml/2006/main">
             <a:pPr>
               <a:defRPr sz="1350" b="1">
+                <a:solidFill>
+                  <a:srgbClr val="F0E8D2"/>
+                </a:solidFill>
                 <a:latin typeface="DM Mono Labels"/>
-                <a:solidFill>
-                  <a:srgbClr val="F0E8D2"/>
-                </a:solidFill>
+                <a:ea typeface="DM Mono Labels"/>
+                <a:cs typeface="DM Mono Labels"/>
               </a:defRPr>
             </a:pPr>
           </a:p>
         </c:txPr>
         <c:crossAx val="48672768"/>
-        <c:lblAlgn val="ctr"/>
         <c:lblOffset val="100"/>
-        <c:noMultiLvlLbl val="0"/>
       </c:catAx>
       <c:valAx>
         <c:axId val="48672768"/>
@@ -2140,6 +2051,9 @@
                         <a:alpha val="72000"/>
                       </a:srgbClr>
                     </a:solidFill>
+                    <a:latin typeface="DM Mono Labels"/>
+                    <a:ea typeface="DM Mono Labels"/>
+                    <a:cs typeface="DM Mono Labels"/>
                   </a:rPr>
                   <a:t>DECAY · SECONDS</a:t>
                 </a:r>
@@ -2152,12 +2066,14 @@
             <a:p xmlns:a="http://schemas.openxmlformats.org/drawingml/2006/main">
               <a:pPr>
                 <a:defRPr sz="1275" b="1">
-                  <a:latin typeface="DM Mono Labels"/>
                   <a:solidFill>
                     <a:srgbClr val="F0E8D2">
                       <a:alpha val="72000"/>
                     </a:srgbClr>
                   </a:solidFill>
+                  <a:latin typeface="DM Mono Labels"/>
+                  <a:ea typeface="DM Mono Labels"/>
+                  <a:cs typeface="DM Mono Labels"/>
                 </a:defRPr>
               </a:pPr>
             </a:p>
@@ -2182,10 +2098,12 @@
           <a:p xmlns:a="http://schemas.openxmlformats.org/drawingml/2006/main">
             <a:pPr>
               <a:defRPr sz="1350" b="1">
+                <a:solidFill>
+                  <a:srgbClr val="F0E8D2"/>
+                </a:solidFill>
                 <a:latin typeface="DM Mono Labels"/>
-                <a:solidFill>
-                  <a:srgbClr val="F0E8D2"/>
-                </a:solidFill>
+                <a:ea typeface="DM Mono Labels"/>
+                <a:cs typeface="DM Mono Labels"/>
               </a:defRPr>
             </a:pPr>
           </a:p>
@@ -2219,10 +2137,12 @@
         <a:p xmlns:a="http://schemas.openxmlformats.org/drawingml/2006/main">
           <a:pPr>
             <a:defRPr sz="1350" b="1">
-              <a:latin typeface="DM Mono Labels"/>
               <a:solidFill>
                 <a:srgbClr val="F0E8D2"/>
               </a:solidFill>
+              <a:latin typeface="DM Mono Labels"/>
+              <a:ea typeface="DM Mono Labels"/>
+              <a:cs typeface="DM Mono Labels"/>
             </a:defRPr>
           </a:pPr>
         </a:p>
@@ -2370,10 +2290,12 @@
             <a:p xmlns:a="http://schemas.openxmlformats.org/drawingml/2006/main">
               <a:pPr>
                 <a:defRPr sz="1350" b="1">
-                  <a:latin typeface="DM Mono Labels"/>
                   <a:solidFill>
                     <a:srgbClr val="232E26"/>
                   </a:solidFill>
+                  <a:latin typeface="DM Mono Labels"/>
+                  <a:ea typeface="DM Mono Labels"/>
+                  <a:cs typeface="DM Mono Labels"/>
                 </a:defRPr>
               </a:pPr>
             </a:p>
@@ -2417,18 +2339,18 @@
           <a:p xmlns:a="http://schemas.openxmlformats.org/drawingml/2006/main">
             <a:pPr>
               <a:defRPr sz="1350" b="1">
+                <a:solidFill>
+                  <a:srgbClr val="232E26"/>
+                </a:solidFill>
                 <a:latin typeface="DM Mono Labels"/>
-                <a:solidFill>
-                  <a:srgbClr val="232E26"/>
-                </a:solidFill>
+                <a:ea typeface="DM Mono Labels"/>
+                <a:cs typeface="DM Mono Labels"/>
               </a:defRPr>
             </a:pPr>
           </a:p>
         </c:txPr>
         <c:crossAx val="48672768"/>
-        <c:lblAlgn val="ctr"/>
         <c:lblOffset val="100"/>
-        <c:noMultiLvlLbl val="0"/>
       </c:catAx>
       <c:valAx>
         <c:axId val="48672768"/>
@@ -2464,6 +2386,9 @@
                         <a:alpha val="70000"/>
                       </a:srgbClr>
                     </a:solidFill>
+                    <a:latin typeface="DM Mono Labels"/>
+                    <a:ea typeface="DM Mono Labels"/>
+                    <a:cs typeface="DM Mono Labels"/>
                   </a:rPr>
                   <a:t>UNINTERRUPTED MINUTES</a:t>
                 </a:r>
@@ -2476,12 +2401,14 @@
             <a:p xmlns:a="http://schemas.openxmlformats.org/drawingml/2006/main">
               <a:pPr>
                 <a:defRPr sz="1275" b="1">
-                  <a:latin typeface="DM Mono Labels"/>
                   <a:solidFill>
                     <a:srgbClr val="232E26">
                       <a:alpha val="70000"/>
                     </a:srgbClr>
                   </a:solidFill>
+                  <a:latin typeface="DM Mono Labels"/>
+                  <a:ea typeface="DM Mono Labels"/>
+                  <a:cs typeface="DM Mono Labels"/>
                 </a:defRPr>
               </a:pPr>
             </a:p>
@@ -2506,10 +2433,12 @@
           <a:p xmlns:a="http://schemas.openxmlformats.org/drawingml/2006/main">
             <a:pPr>
               <a:defRPr sz="1350" b="1">
+                <a:solidFill>
+                  <a:srgbClr val="232E26"/>
+                </a:solidFill>
                 <a:latin typeface="DM Mono Labels"/>
-                <a:solidFill>
-                  <a:srgbClr val="232E26"/>
-                </a:solidFill>
+                <a:ea typeface="DM Mono Labels"/>
+                <a:cs typeface="DM Mono Labels"/>
               </a:defRPr>
             </a:pPr>
           </a:p>
@@ -2539,10 +2468,12 @@
         <a:p xmlns:a="http://schemas.openxmlformats.org/drawingml/2006/main">
           <a:pPr>
             <a:defRPr sz="1350" b="1">
-              <a:latin typeface="DM Mono Labels"/>
               <a:solidFill>
                 <a:srgbClr val="232E26"/>
               </a:solidFill>
+              <a:latin typeface="DM Mono Labels"/>
+              <a:ea typeface="DM Mono Labels"/>
+              <a:cs typeface="DM Mono Labels"/>
             </a:defRPr>
           </a:pPr>
         </a:p>
@@ -2569,9 +2500,23 @@
   <p:cSld>
     <p:bg>
       <p:bgPr>
-        <a:solidFill xmlns:a="http://schemas.openxmlformats.org/drawingml/2006/main">
-          <a:srgbClr val="232E26"/>
-        </a:solidFill>
+        <a:gradFill xmlns:a="http://schemas.openxmlformats.org/drawingml/2006/main">
+          <a:gsLst>
+            <a:gs pos="0">
+              <a:srgbClr val="232E26"/>
+            </a:gs>
+            <a:gs pos="56000">
+              <a:srgbClr val="232E26"/>
+            </a:gs>
+            <a:gs pos="78000">
+              <a:srgbClr val="2B3026"/>
+            </a:gs>
+            <a:gs pos="100000">
+              <a:srgbClr val="514029"/>
+            </a:gs>
+          </a:gsLst>
+          <a:lin ang="2700000"/>
+        </a:gradFill>
       </p:bgPr>
     </p:bg>
     <p:spTree>
@@ -2585,54 +2530,6 @@
       </p:grpSpPr>
       <p:sp>
         <p:nvSpPr>
-          <p:cNvPr id="1" name="mat-cover-wood-glow">
-            <a:extLst xmlns:a="http://schemas.openxmlformats.org/drawingml/2006/main">
-              <a:ext uri="{FF2B5EF4-FFF2-40B4-BE49-F238E27FC236}">
-                <a16:creationId xmlns:a16="http://schemas.microsoft.com/office/drawing/2014/main" id="{7F851CA7-7351-40B0-A476-68F295DC779B}"/>
-              </a:ext>
-            </a:extLst>
-          </p:cNvPr>
-          <p:cNvSpPr>
-            <a:spLocks xmlns:a="http://schemas.openxmlformats.org/drawingml/2006/main" noGrp="1"/>
-          </p:cNvSpPr>
-          <p:nvPr/>
-        </p:nvSpPr>
-        <p:spPr>
-          <a:xfrm xmlns:a="http://schemas.openxmlformats.org/drawingml/2006/main">
-            <a:off x="7810500" y="3371850"/>
-            <a:ext cx="4324350" cy="3276600"/>
-          </a:xfrm>
-          <a:prstGeom xmlns:a="http://schemas.openxmlformats.org/drawingml/2006/main" prst="ellipse">
-            <a:avLst/>
-          </a:prstGeom>
-          <a:gradFill xmlns:a="http://schemas.openxmlformats.org/drawingml/2006/main">
-            <a:gsLst>
-              <a:gs pos="0">
-                <a:srgbClr val="7A4E24">
-                  <a:alpha val="34000"/>
-                </a:srgbClr>
-              </a:gs>
-              <a:gs pos="46000">
-                <a:srgbClr val="7A4E24">
-                  <a:alpha val="14000"/>
-                </a:srgbClr>
-              </a:gs>
-              <a:gs pos="100000">
-                <a:srgbClr val="232E26">
-                  <a:alpha val="0"/>
-                </a:srgbClr>
-              </a:gs>
-            </a:gsLst>
-            <a:path path="shape"/>
-          </a:gradFill>
-          <a:ln xmlns:a="http://schemas.openxmlformats.org/drawingml/2006/main" w="0">
-            <a:noFill/>
-            <a:prstDash val="solid"/>
-          </a:ln>
-        </p:spPr>
-      </p:sp>
-      <p:sp>
-        <p:nvSpPr>
           <p:cNvPr id="2" name="mat-cover-kicker">
             <a:extLst xmlns:a="http://schemas.openxmlformats.org/drawingml/2006/main">
               <a:ext uri="{FF2B5EF4-FFF2-40B4-BE49-F238E27FC236}">
@@ -2666,6 +2563,7 @@
           <a:lstStyle xmlns:a="http://schemas.openxmlformats.org/drawingml/2006/main"/>
           <a:p xmlns:a="http://schemas.openxmlformats.org/drawingml/2006/main">
             <a:pPr algn="l">
+              <a:buNone/>
               <a:defRPr sz="1050" b="0" i="0">
                 <a:solidFill>
                   <a:srgbClr val="C07030"/>
@@ -2826,7 +2724,7 @@
         <p:spPr>
           <a:xfrm xmlns:a="http://schemas.openxmlformats.org/drawingml/2006/main">
             <a:off x="800100" y="4819650"/>
-            <a:ext cx="7239000" cy="685800"/>
+            <a:ext cx="8382000" cy="990600"/>
           </a:xfrm>
           <a:prstGeom xmlns:a="http://schemas.openxmlformats.org/drawingml/2006/main" prst="rect">
             <a:avLst/>
@@ -2839,7 +2737,7 @@
         </p:spPr>
         <p:txBody>
           <a:bodyPr xmlns:a="http://schemas.openxmlformats.org/drawingml/2006/main" wrap="square" lIns="0" tIns="0" rIns="0" bIns="0" anchor="t">
-            <a:normAutofit fontScale="93985"/>
+            <a:normAutofit fontScale="100000"/>
           </a:bodyPr>
           <a:lstStyle xmlns:a="http://schemas.openxmlformats.org/drawingml/2006/main"/>
           <a:p xmlns:a="http://schemas.openxmlformats.org/drawingml/2006/main">
@@ -2866,7 +2764,7 @@
                 <a:ea typeface="DM Sans Text"/>
                 <a:cs typeface="DM Sans Text"/>
               </a:rPr>
-              <a:t>A small field guide to rooms that disappear when the music starts.</a:t>
+              <a:t>A small field guide to listening rooms that disappear when the music starts, leaving nothing between the listener and the record.</a:t>
             </a:r>
           </a:p>
         </p:txBody>
@@ -2906,6 +2804,7 @@
           <a:lstStyle xmlns:a="http://schemas.openxmlformats.org/drawingml/2006/main"/>
           <a:p xmlns:a="http://schemas.openxmlformats.org/drawingml/2006/main">
             <a:pPr algn="l">
+              <a:buNone/>
               <a:defRPr sz="900" b="0" i="0">
                 <a:solidFill>
                   <a:srgbClr val="F0E8D2">
@@ -2929,64 +2828,6 @@
                 <a:cs typeface="DM Mono Labels"/>
               </a:rPr>
               <a:t>LISTENING NOTE 01 / 2026</a:t>
-            </a:r>
-          </a:p>
-        </p:txBody>
-      </p:sp>
-      <p:sp>
-        <p:nvSpPr>
-          <p:cNvPr id="7" name="mat-cover-mark">
-            <a:extLst xmlns:a="http://schemas.openxmlformats.org/drawingml/2006/main">
-              <a:ext uri="{FF2B5EF4-FFF2-40B4-BE49-F238E27FC236}">
-                <a16:creationId xmlns:a16="http://schemas.microsoft.com/office/drawing/2014/main" id="{F01D7E5F-22FD-410F-9C72-1A614E8D3770}"/>
-              </a:ext>
-            </a:extLst>
-          </p:cNvPr>
-          <p:cNvSpPr>
-            <a:spLocks xmlns:a="http://schemas.openxmlformats.org/drawingml/2006/main" noGrp="1"/>
-          </p:cNvSpPr>
-          <p:nvPr/>
-        </p:nvSpPr>
-        <p:spPr>
-          <a:xfrm xmlns:a="http://schemas.openxmlformats.org/drawingml/2006/main">
-            <a:off x="9677400" y="4914900"/>
-            <a:ext cx="1638300" cy="838200"/>
-          </a:xfrm>
-          <a:prstGeom xmlns:a="http://schemas.openxmlformats.org/drawingml/2006/main" prst="rect">
-            <a:avLst/>
-          </a:prstGeom>
-          <a:noFill xmlns:a="http://schemas.openxmlformats.org/drawingml/2006/main"/>
-          <a:ln xmlns:a="http://schemas.openxmlformats.org/drawingml/2006/main" w="0">
-            <a:noFill/>
-            <a:prstDash val="solid"/>
-          </a:ln>
-        </p:spPr>
-        <p:txBody>
-          <a:bodyPr xmlns:a="http://schemas.openxmlformats.org/drawingml/2006/main" wrap="square" lIns="0" tIns="0" rIns="0" bIns="0" anchor="ctr">
-            <a:normAutofit fontScale="100000"/>
-          </a:bodyPr>
-          <a:lstStyle xmlns:a="http://schemas.openxmlformats.org/drawingml/2006/main"/>
-          <a:p xmlns:a="http://schemas.openxmlformats.org/drawingml/2006/main">
-            <a:pPr algn="r">
-              <a:defRPr sz="4500" b="1" i="0">
-                <a:solidFill>
-                  <a:srgbClr val="C07030"/>
-                </a:solidFill>
-                <a:latin typeface="Bricolage Grotesque Heading"/>
-                <a:ea typeface="Bricolage Grotesque Heading"/>
-                <a:cs typeface="Bricolage Grotesque Heading"/>
-              </a:defRPr>
-            </a:pPr>
-            <a:r>
-              <a:rPr sz="4500" b="1" i="0">
-                <a:solidFill>
-                  <a:srgbClr val="C07030"/>
-                </a:solidFill>
-                <a:latin typeface="Bricolage Grotesque Heading"/>
-                <a:ea typeface="Bricolage Grotesque Heading"/>
-                <a:cs typeface="Bricolage Grotesque Heading"/>
-              </a:rPr>
-              <a:t>33⅓</a:t>
             </a:r>
           </a:p>
         </p:txBody>
@@ -3022,7 +2863,7 @@
       </p:grpSpPr>
       <p:sp>
         <p:nvSpPr>
-          <p:cNvPr id="1" name="mat-top-rule-2">
+          <p:cNvPr id="21" name="mat-top-rule-2">
             <a:extLst xmlns:a="http://schemas.openxmlformats.org/drawingml/2006/main">
               <a:ext uri="{FF2B5EF4-FFF2-40B4-BE49-F238E27FC236}">
                 <a16:creationId xmlns:a16="http://schemas.microsoft.com/office/drawing/2014/main" id="{6DB7ECB2-37B8-418D-BD73-DE9DE2E3B345}"/>
@@ -3088,6 +2929,7 @@
           <a:lstStyle xmlns:a="http://schemas.openxmlformats.org/drawingml/2006/main"/>
           <a:p xmlns:a="http://schemas.openxmlformats.org/drawingml/2006/main">
             <a:pPr algn="l">
+              <a:buNone/>
               <a:defRPr sz="975" b="0" i="0">
                 <a:solidFill>
                   <a:srgbClr val="232E26"/>
@@ -3146,6 +2988,7 @@
           <a:lstStyle xmlns:a="http://schemas.openxmlformats.org/drawingml/2006/main"/>
           <a:p xmlns:a="http://schemas.openxmlformats.org/drawingml/2006/main">
             <a:pPr algn="r">
+              <a:buNone/>
               <a:defRPr sz="975" b="0" i="0">
                 <a:solidFill>
                   <a:srgbClr val="232E26"/>
@@ -3237,6 +3080,7 @@
           <a:lstStyle xmlns:a="http://schemas.openxmlformats.org/drawingml/2006/main"/>
           <a:p xmlns:a="http://schemas.openxmlformats.org/drawingml/2006/main">
             <a:pPr algn="l">
+              <a:buNone/>
               <a:defRPr sz="750" b="0" i="0">
                 <a:solidFill>
                   <a:srgbClr val="232E26">
@@ -3299,6 +3143,7 @@
           <a:lstStyle xmlns:a="http://schemas.openxmlformats.org/drawingml/2006/main"/>
           <a:p xmlns:a="http://schemas.openxmlformats.org/drawingml/2006/main">
             <a:pPr algn="l">
+              <a:buNone/>
               <a:defRPr sz="1050" b="0" i="0">
                 <a:solidFill>
                   <a:srgbClr val="C07030"/>
@@ -3419,6 +3264,7 @@
           <a:lstStyle xmlns:a="http://schemas.openxmlformats.org/drawingml/2006/main"/>
           <a:p xmlns:a="http://schemas.openxmlformats.org/drawingml/2006/main">
             <a:pPr algn="l">
+              <a:buNone/>
               <a:defRPr sz="3150" b="1" i="0">
                 <a:solidFill>
                   <a:srgbClr val="C07030"/>
@@ -3510,6 +3356,7 @@
           <a:lstStyle xmlns:a="http://schemas.openxmlformats.org/drawingml/2006/main"/>
           <a:p xmlns:a="http://schemas.openxmlformats.org/drawingml/2006/main">
             <a:pPr algn="l">
+              <a:buNone/>
               <a:defRPr sz="1050" b="0" i="0">
                 <a:solidFill>
                   <a:srgbClr val="C07030"/>
@@ -3568,6 +3415,7 @@
           <a:lstStyle xmlns:a="http://schemas.openxmlformats.org/drawingml/2006/main"/>
           <a:p xmlns:a="http://schemas.openxmlformats.org/drawingml/2006/main">
             <a:pPr algn="l">
+              <a:buNone/>
               <a:defRPr sz="1950" b="1" i="0">
                 <a:solidFill>
                   <a:srgbClr val="232E26"/>
@@ -3626,6 +3474,7 @@
           <a:lstStyle xmlns:a="http://schemas.openxmlformats.org/drawingml/2006/main"/>
           <a:p xmlns:a="http://schemas.openxmlformats.org/drawingml/2006/main">
             <a:pPr algn="l">
+              <a:buNone/>
               <a:defRPr sz="1425" b="0" i="0">
                 <a:solidFill>
                   <a:srgbClr val="1E2820"/>
@@ -3717,6 +3566,7 @@
           <a:lstStyle xmlns:a="http://schemas.openxmlformats.org/drawingml/2006/main"/>
           <a:p xmlns:a="http://schemas.openxmlformats.org/drawingml/2006/main">
             <a:pPr algn="l">
+              <a:buNone/>
               <a:defRPr sz="1050" b="0" i="0">
                 <a:solidFill>
                   <a:srgbClr val="C07030"/>
@@ -3775,6 +3625,7 @@
           <a:lstStyle xmlns:a="http://schemas.openxmlformats.org/drawingml/2006/main"/>
           <a:p xmlns:a="http://schemas.openxmlformats.org/drawingml/2006/main">
             <a:pPr algn="l">
+              <a:buNone/>
               <a:defRPr sz="1950" b="1" i="0">
                 <a:solidFill>
                   <a:srgbClr val="232E26"/>
@@ -3833,6 +3684,7 @@
           <a:lstStyle xmlns:a="http://schemas.openxmlformats.org/drawingml/2006/main"/>
           <a:p xmlns:a="http://schemas.openxmlformats.org/drawingml/2006/main">
             <a:pPr algn="l">
+              <a:buNone/>
               <a:defRPr sz="1425" b="0" i="0">
                 <a:solidFill>
                   <a:srgbClr val="1E2820"/>
@@ -3924,6 +3776,7 @@
           <a:lstStyle xmlns:a="http://schemas.openxmlformats.org/drawingml/2006/main"/>
           <a:p xmlns:a="http://schemas.openxmlformats.org/drawingml/2006/main">
             <a:pPr algn="l">
+              <a:buNone/>
               <a:defRPr sz="1050" b="0" i="0">
                 <a:solidFill>
                   <a:srgbClr val="C07030"/>
@@ -3982,6 +3835,7 @@
           <a:lstStyle xmlns:a="http://schemas.openxmlformats.org/drawingml/2006/main"/>
           <a:p xmlns:a="http://schemas.openxmlformats.org/drawingml/2006/main">
             <a:pPr algn="l">
+              <a:buNone/>
               <a:defRPr sz="1950" b="1" i="0">
                 <a:solidFill>
                   <a:srgbClr val="232E26"/>
@@ -4040,6 +3894,7 @@
           <a:lstStyle xmlns:a="http://schemas.openxmlformats.org/drawingml/2006/main"/>
           <a:p xmlns:a="http://schemas.openxmlformats.org/drawingml/2006/main">
             <a:pPr algn="l">
+              <a:buNone/>
               <a:defRPr sz="1425" b="0" i="0">
                 <a:solidFill>
                   <a:srgbClr val="1E2820"/>
@@ -4078,9 +3933,23 @@
   <p:cSld>
     <p:bg>
       <p:bgPr>
-        <a:solidFill xmlns:a="http://schemas.openxmlformats.org/drawingml/2006/main">
-          <a:srgbClr val="232E26"/>
-        </a:solidFill>
+        <a:gradFill xmlns:a="http://schemas.openxmlformats.org/drawingml/2006/main">
+          <a:gsLst>
+            <a:gs pos="0">
+              <a:srgbClr val="232E26"/>
+            </a:gs>
+            <a:gs pos="56000">
+              <a:srgbClr val="232E26"/>
+            </a:gs>
+            <a:gs pos="78000">
+              <a:srgbClr val="2B3026"/>
+            </a:gs>
+            <a:gs pos="100000">
+              <a:srgbClr val="514029"/>
+            </a:gs>
+          </a:gsLst>
+          <a:lin ang="2700000"/>
+        </a:gradFill>
       </p:bgPr>
     </p:bg>
     <p:spTree>
@@ -4094,54 +3963,6 @@
       </p:grpSpPr>
       <p:sp>
         <p:nvSpPr>
-          <p:cNvPr id="1" name="mat-layers-wood-glow">
-            <a:extLst xmlns:a="http://schemas.openxmlformats.org/drawingml/2006/main">
-              <a:ext uri="{FF2B5EF4-FFF2-40B4-BE49-F238E27FC236}">
-                <a16:creationId xmlns:a16="http://schemas.microsoft.com/office/drawing/2014/main" id="{5968D4F0-B8D0-46A0-A32A-DB6AAF59B369}"/>
-              </a:ext>
-            </a:extLst>
-          </p:cNvPr>
-          <p:cNvSpPr>
-            <a:spLocks xmlns:a="http://schemas.openxmlformats.org/drawingml/2006/main" noGrp="1"/>
-          </p:cNvSpPr>
-          <p:nvPr/>
-        </p:nvSpPr>
-        <p:spPr>
-          <a:xfrm xmlns:a="http://schemas.openxmlformats.org/drawingml/2006/main">
-            <a:off x="7810500" y="3371850"/>
-            <a:ext cx="4324350" cy="3276600"/>
-          </a:xfrm>
-          <a:prstGeom xmlns:a="http://schemas.openxmlformats.org/drawingml/2006/main" prst="ellipse">
-            <a:avLst/>
-          </a:prstGeom>
-          <a:gradFill xmlns:a="http://schemas.openxmlformats.org/drawingml/2006/main">
-            <a:gsLst>
-              <a:gs pos="0">
-                <a:srgbClr val="7A4E24">
-                  <a:alpha val="34000"/>
-                </a:srgbClr>
-              </a:gs>
-              <a:gs pos="46000">
-                <a:srgbClr val="7A4E24">
-                  <a:alpha val="14000"/>
-                </a:srgbClr>
-              </a:gs>
-              <a:gs pos="100000">
-                <a:srgbClr val="232E26">
-                  <a:alpha val="0"/>
-                </a:srgbClr>
-              </a:gs>
-            </a:gsLst>
-            <a:path path="shape"/>
-          </a:gradFill>
-          <a:ln xmlns:a="http://schemas.openxmlformats.org/drawingml/2006/main" w="0">
-            <a:noFill/>
-            <a:prstDash val="solid"/>
-          </a:ln>
-        </p:spPr>
-      </p:sp>
-      <p:sp>
-        <p:nvSpPr>
           <p:cNvPr id="2" name="mat-top-rule-3">
             <a:extLst xmlns:a="http://schemas.openxmlformats.org/drawingml/2006/main">
               <a:ext uri="{FF2B5EF4-FFF2-40B4-BE49-F238E27FC236}">
@@ -4208,6 +4029,7 @@
           <a:lstStyle xmlns:a="http://schemas.openxmlformats.org/drawingml/2006/main"/>
           <a:p xmlns:a="http://schemas.openxmlformats.org/drawingml/2006/main">
             <a:pPr algn="l">
+              <a:buNone/>
               <a:defRPr sz="975" b="0" i="0">
                 <a:solidFill>
                   <a:srgbClr val="F0E8D2"/>
@@ -4266,6 +4088,7 @@
           <a:lstStyle xmlns:a="http://schemas.openxmlformats.org/drawingml/2006/main"/>
           <a:p xmlns:a="http://schemas.openxmlformats.org/drawingml/2006/main">
             <a:pPr algn="r">
+              <a:buNone/>
               <a:defRPr sz="975" b="0" i="0">
                 <a:solidFill>
                   <a:srgbClr val="F0E8D2"/>
@@ -4357,6 +4180,7 @@
           <a:lstStyle xmlns:a="http://schemas.openxmlformats.org/drawingml/2006/main"/>
           <a:p xmlns:a="http://schemas.openxmlformats.org/drawingml/2006/main">
             <a:pPr algn="l">
+              <a:buNone/>
               <a:defRPr sz="750" b="0" i="0">
                 <a:solidFill>
                   <a:srgbClr val="F0E8D2">
@@ -4605,6 +4429,7 @@
           <a:lstStyle xmlns:a="http://schemas.openxmlformats.org/drawingml/2006/main"/>
           <a:p xmlns:a="http://schemas.openxmlformats.org/drawingml/2006/main">
             <a:pPr algn="l">
+              <a:buNone/>
               <a:defRPr sz="975" b="0" i="0">
                 <a:solidFill>
                   <a:srgbClr val="C07030"/>
@@ -4696,6 +4521,7 @@
           <a:lstStyle xmlns:a="http://schemas.openxmlformats.org/drawingml/2006/main"/>
           <a:p xmlns:a="http://schemas.openxmlformats.org/drawingml/2006/main">
             <a:pPr algn="l">
+              <a:buNone/>
               <a:defRPr sz="975" b="0" i="0">
                 <a:solidFill>
                   <a:srgbClr val="C07030"/>
@@ -4754,6 +4580,7 @@
           <a:lstStyle xmlns:a="http://schemas.openxmlformats.org/drawingml/2006/main"/>
           <a:p xmlns:a="http://schemas.openxmlformats.org/drawingml/2006/main">
             <a:pPr algn="l">
+              <a:buNone/>
               <a:defRPr sz="1800" b="1" i="0">
                 <a:solidFill>
                   <a:srgbClr val="232E26"/>
@@ -4907,6 +4734,7 @@
           <a:lstStyle xmlns:a="http://schemas.openxmlformats.org/drawingml/2006/main"/>
           <a:p xmlns:a="http://schemas.openxmlformats.org/drawingml/2006/main">
             <a:pPr algn="l">
+              <a:buNone/>
               <a:defRPr sz="975" b="0" i="0">
                 <a:solidFill>
                   <a:srgbClr val="C07030"/>
@@ -4965,6 +4793,7 @@
           <a:lstStyle xmlns:a="http://schemas.openxmlformats.org/drawingml/2006/main"/>
           <a:p xmlns:a="http://schemas.openxmlformats.org/drawingml/2006/main">
             <a:pPr algn="l">
+              <a:buNone/>
               <a:defRPr sz="1800" b="1" i="0">
                 <a:solidFill>
                   <a:srgbClr val="232E26"/>
@@ -5118,6 +4947,7 @@
           <a:lstStyle xmlns:a="http://schemas.openxmlformats.org/drawingml/2006/main"/>
           <a:p xmlns:a="http://schemas.openxmlformats.org/drawingml/2006/main">
             <a:pPr algn="l">
+              <a:buNone/>
               <a:defRPr sz="975" b="0" i="0">
                 <a:solidFill>
                   <a:srgbClr val="C07030"/>
@@ -5176,6 +5006,7 @@
           <a:lstStyle xmlns:a="http://schemas.openxmlformats.org/drawingml/2006/main"/>
           <a:p xmlns:a="http://schemas.openxmlformats.org/drawingml/2006/main">
             <a:pPr algn="l">
+              <a:buNone/>
               <a:defRPr sz="1800" b="1" i="0">
                 <a:solidFill>
                   <a:srgbClr val="232E26"/>
@@ -5329,6 +5160,7 @@
           <a:lstStyle xmlns:a="http://schemas.openxmlformats.org/drawingml/2006/main"/>
           <a:p xmlns:a="http://schemas.openxmlformats.org/drawingml/2006/main">
             <a:pPr algn="l">
+              <a:buNone/>
               <a:defRPr sz="975" b="0" i="0">
                 <a:solidFill>
                   <a:srgbClr val="C07030"/>
@@ -5387,6 +5219,7 @@
           <a:lstStyle xmlns:a="http://schemas.openxmlformats.org/drawingml/2006/main"/>
           <a:p xmlns:a="http://schemas.openxmlformats.org/drawingml/2006/main">
             <a:pPr algn="l">
+              <a:buNone/>
               <a:defRPr sz="1800" b="1" i="0">
                 <a:solidFill>
                   <a:srgbClr val="232E26"/>
@@ -5503,7 +5336,7 @@
       </p:grpSpPr>
       <p:sp>
         <p:nvSpPr>
-          <p:cNvPr id="1" name="mat-top-rule-4">
+          <p:cNvPr id="21" name="mat-top-rule-4">
             <a:extLst xmlns:a="http://schemas.openxmlformats.org/drawingml/2006/main">
               <a:ext uri="{FF2B5EF4-FFF2-40B4-BE49-F238E27FC236}">
                 <a16:creationId xmlns:a16="http://schemas.microsoft.com/office/drawing/2014/main" id="{813FCE9B-E297-4B6B-A3B8-1A5EAE48480E}"/>
@@ -5569,6 +5402,7 @@
           <a:lstStyle xmlns:a="http://schemas.openxmlformats.org/drawingml/2006/main"/>
           <a:p xmlns:a="http://schemas.openxmlformats.org/drawingml/2006/main">
             <a:pPr algn="l">
+              <a:buNone/>
               <a:defRPr sz="975" b="0" i="0">
                 <a:solidFill>
                   <a:srgbClr val="232E26"/>
@@ -5627,6 +5461,7 @@
           <a:lstStyle xmlns:a="http://schemas.openxmlformats.org/drawingml/2006/main"/>
           <a:p xmlns:a="http://schemas.openxmlformats.org/drawingml/2006/main">
             <a:pPr algn="r">
+              <a:buNone/>
               <a:defRPr sz="975" b="0" i="0">
                 <a:solidFill>
                   <a:srgbClr val="232E26"/>
@@ -5718,6 +5553,7 @@
           <a:lstStyle xmlns:a="http://schemas.openxmlformats.org/drawingml/2006/main"/>
           <a:p xmlns:a="http://schemas.openxmlformats.org/drawingml/2006/main">
             <a:pPr algn="l">
+              <a:buNone/>
               <a:defRPr sz="750" b="0" i="0">
                 <a:solidFill>
                   <a:srgbClr val="232E26">
@@ -5780,6 +5616,7 @@
           <a:lstStyle xmlns:a="http://schemas.openxmlformats.org/drawingml/2006/main"/>
           <a:p xmlns:a="http://schemas.openxmlformats.org/drawingml/2006/main">
             <a:pPr algn="l">
+              <a:buNone/>
               <a:defRPr sz="3900" b="1" i="0">
                 <a:solidFill>
                   <a:srgbClr val="232E26"/>
@@ -5999,6 +5836,7 @@
           <a:lstStyle xmlns:a="http://schemas.openxmlformats.org/drawingml/2006/main"/>
           <a:p xmlns:a="http://schemas.openxmlformats.org/drawingml/2006/main">
             <a:pPr algn="l">
+              <a:buNone/>
               <a:defRPr sz="5400" b="1" i="0">
                 <a:solidFill>
                   <a:srgbClr val="232E26"/>
@@ -6057,6 +5895,7 @@
           <a:lstStyle xmlns:a="http://schemas.openxmlformats.org/drawingml/2006/main"/>
           <a:p xmlns:a="http://schemas.openxmlformats.org/drawingml/2006/main">
             <a:pPr algn="l">
+              <a:buNone/>
               <a:defRPr sz="1050" b="0" i="0">
                 <a:solidFill>
                   <a:srgbClr val="C07030"/>
@@ -6177,6 +6016,7 @@
           <a:lstStyle xmlns:a="http://schemas.openxmlformats.org/drawingml/2006/main"/>
           <a:p xmlns:a="http://schemas.openxmlformats.org/drawingml/2006/main">
             <a:pPr algn="l">
+              <a:buNone/>
               <a:defRPr sz="5400" b="1" i="0">
                 <a:solidFill>
                   <a:srgbClr val="232E26"/>
@@ -6235,6 +6075,7 @@
           <a:lstStyle xmlns:a="http://schemas.openxmlformats.org/drawingml/2006/main"/>
           <a:p xmlns:a="http://schemas.openxmlformats.org/drawingml/2006/main">
             <a:pPr algn="l">
+              <a:buNone/>
               <a:defRPr sz="1050" b="0" i="0">
                 <a:solidFill>
                   <a:srgbClr val="C07030"/>
@@ -6355,6 +6196,7 @@
           <a:lstStyle xmlns:a="http://schemas.openxmlformats.org/drawingml/2006/main"/>
           <a:p xmlns:a="http://schemas.openxmlformats.org/drawingml/2006/main">
             <a:pPr algn="l">
+              <a:buNone/>
               <a:defRPr sz="5400" b="1" i="0">
                 <a:solidFill>
                   <a:srgbClr val="232E26"/>
@@ -6413,6 +6255,7 @@
           <a:lstStyle xmlns:a="http://schemas.openxmlformats.org/drawingml/2006/main"/>
           <a:p xmlns:a="http://schemas.openxmlformats.org/drawingml/2006/main">
             <a:pPr algn="l">
+              <a:buNone/>
               <a:defRPr sz="1050" b="0" i="0">
                 <a:solidFill>
                   <a:srgbClr val="C07030"/>
@@ -6533,6 +6376,7 @@
           <a:lstStyle xmlns:a="http://schemas.openxmlformats.org/drawingml/2006/main"/>
           <a:p xmlns:a="http://schemas.openxmlformats.org/drawingml/2006/main">
             <a:pPr algn="l">
+              <a:buNone/>
               <a:defRPr sz="825" b="0" i="0">
                 <a:solidFill>
                   <a:srgbClr val="C07030"/>
@@ -6571,9 +6415,23 @@
   <p:cSld>
     <p:bg>
       <p:bgPr>
-        <a:solidFill xmlns:a="http://schemas.openxmlformats.org/drawingml/2006/main">
-          <a:srgbClr val="232E26"/>
-        </a:solidFill>
+        <a:gradFill xmlns:a="http://schemas.openxmlformats.org/drawingml/2006/main">
+          <a:gsLst>
+            <a:gs pos="0">
+              <a:srgbClr val="232E26"/>
+            </a:gs>
+            <a:gs pos="56000">
+              <a:srgbClr val="232E26"/>
+            </a:gs>
+            <a:gs pos="78000">
+              <a:srgbClr val="2B3026"/>
+            </a:gs>
+            <a:gs pos="100000">
+              <a:srgbClr val="514029"/>
+            </a:gs>
+          </a:gsLst>
+          <a:lin ang="2700000"/>
+        </a:gradFill>
       </p:bgPr>
     </p:bg>
     <p:spTree>
@@ -6587,54 +6445,6 @@
       </p:grpSpPr>
       <p:sp>
         <p:nvSpPr>
-          <p:cNvPr id="1" name="mat-decay-wood-glow">
-            <a:extLst xmlns:a="http://schemas.openxmlformats.org/drawingml/2006/main">
-              <a:ext uri="{FF2B5EF4-FFF2-40B4-BE49-F238E27FC236}">
-                <a16:creationId xmlns:a16="http://schemas.microsoft.com/office/drawing/2014/main" id="{52E4AB02-7595-42F2-BDC0-95400FCCE2B9}"/>
-              </a:ext>
-            </a:extLst>
-          </p:cNvPr>
-          <p:cNvSpPr>
-            <a:spLocks xmlns:a="http://schemas.openxmlformats.org/drawingml/2006/main" noGrp="1"/>
-          </p:cNvSpPr>
-          <p:nvPr/>
-        </p:nvSpPr>
-        <p:spPr>
-          <a:xfrm xmlns:a="http://schemas.openxmlformats.org/drawingml/2006/main">
-            <a:off x="7810500" y="3371850"/>
-            <a:ext cx="4324350" cy="3276600"/>
-          </a:xfrm>
-          <a:prstGeom xmlns:a="http://schemas.openxmlformats.org/drawingml/2006/main" prst="ellipse">
-            <a:avLst/>
-          </a:prstGeom>
-          <a:gradFill xmlns:a="http://schemas.openxmlformats.org/drawingml/2006/main">
-            <a:gsLst>
-              <a:gs pos="0">
-                <a:srgbClr val="7A4E24">
-                  <a:alpha val="34000"/>
-                </a:srgbClr>
-              </a:gs>
-              <a:gs pos="46000">
-                <a:srgbClr val="7A4E24">
-                  <a:alpha val="14000"/>
-                </a:srgbClr>
-              </a:gs>
-              <a:gs pos="100000">
-                <a:srgbClr val="232E26">
-                  <a:alpha val="0"/>
-                </a:srgbClr>
-              </a:gs>
-            </a:gsLst>
-            <a:path path="shape"/>
-          </a:gradFill>
-          <a:ln xmlns:a="http://schemas.openxmlformats.org/drawingml/2006/main" w="0">
-            <a:noFill/>
-            <a:prstDash val="solid"/>
-          </a:ln>
-        </p:spPr>
-      </p:sp>
-      <p:sp>
-        <p:nvSpPr>
           <p:cNvPr id="2" name="mat-top-rule-5">
             <a:extLst xmlns:a="http://schemas.openxmlformats.org/drawingml/2006/main">
               <a:ext uri="{FF2B5EF4-FFF2-40B4-BE49-F238E27FC236}">
@@ -6701,6 +6511,7 @@
           <a:lstStyle xmlns:a="http://schemas.openxmlformats.org/drawingml/2006/main"/>
           <a:p xmlns:a="http://schemas.openxmlformats.org/drawingml/2006/main">
             <a:pPr algn="l">
+              <a:buNone/>
               <a:defRPr sz="975" b="0" i="0">
                 <a:solidFill>
                   <a:srgbClr val="F0E8D2"/>
@@ -6759,6 +6570,7 @@
           <a:lstStyle xmlns:a="http://schemas.openxmlformats.org/drawingml/2006/main"/>
           <a:p xmlns:a="http://schemas.openxmlformats.org/drawingml/2006/main">
             <a:pPr algn="r">
+              <a:buNone/>
               <a:defRPr sz="975" b="0" i="0">
                 <a:solidFill>
                   <a:srgbClr val="F0E8D2"/>
@@ -6850,6 +6662,7 @@
           <a:lstStyle xmlns:a="http://schemas.openxmlformats.org/drawingml/2006/main"/>
           <a:p xmlns:a="http://schemas.openxmlformats.org/drawingml/2006/main">
             <a:pPr algn="l">
+              <a:buNone/>
               <a:defRPr sz="750" b="0" i="0">
                 <a:solidFill>
                   <a:srgbClr val="F0E8D2">
@@ -6912,6 +6725,7 @@
           <a:lstStyle xmlns:a="http://schemas.openxmlformats.org/drawingml/2006/main"/>
           <a:p xmlns:a="http://schemas.openxmlformats.org/drawingml/2006/main">
             <a:pPr algn="l">
+              <a:buNone/>
               <a:defRPr sz="3675" b="1" i="0">
                 <a:solidFill>
                   <a:srgbClr val="F0E8D2"/>
@@ -6970,6 +6784,7 @@
           <a:lstStyle xmlns:a="http://schemas.openxmlformats.org/drawingml/2006/main"/>
           <a:p xmlns:a="http://schemas.openxmlformats.org/drawingml/2006/main">
             <a:pPr algn="l">
+              <a:buNone/>
               <a:defRPr sz="1425" b="0" i="0">
                 <a:solidFill>
                   <a:srgbClr val="F0E8D2">
@@ -7009,7 +6824,7 @@
         </p:xfrm>
         <a:graphic xmlns:a="http://schemas.openxmlformats.org/drawingml/2006/main">
           <a:graphicData uri="http://schemas.openxmlformats.org/drawingml/2006/chart">
-            <c:chart xmlns:r="http://schemas.openxmlformats.org/officeDocument/2006/relationships" xmlns:c="http://schemas.openxmlformats.org/drawingml/2006/chart" r:id="Rdde3b38529d546a6"/>
+            <c:chart xmlns:r="http://schemas.openxmlformats.org/officeDocument/2006/relationships" xmlns:c="http://schemas.openxmlformats.org/drawingml/2006/chart" r:id="Refd3c8156a0f47df"/>
           </a:graphicData>
         </a:graphic>
       </p:graphicFrame>
@@ -7048,6 +6863,7 @@
           <a:lstStyle xmlns:a="http://schemas.openxmlformats.org/drawingml/2006/main"/>
           <a:p xmlns:a="http://schemas.openxmlformats.org/drawingml/2006/main">
             <a:pPr algn="l">
+              <a:buNone/>
               <a:defRPr sz="825" b="0" i="0">
                 <a:solidFill>
                   <a:srgbClr val="C07030"/>
@@ -7102,7 +6918,7 @@
       </p:grpSpPr>
       <p:sp>
         <p:nvSpPr>
-          <p:cNvPr id="1" name="mat-top-rule-6">
+          <p:cNvPr id="11" name="mat-top-rule-6">
             <a:extLst xmlns:a="http://schemas.openxmlformats.org/drawingml/2006/main">
               <a:ext uri="{FF2B5EF4-FFF2-40B4-BE49-F238E27FC236}">
                 <a16:creationId xmlns:a16="http://schemas.microsoft.com/office/drawing/2014/main" id="{B6965FD2-1631-4E32-869A-3095D8155D17}"/>
@@ -7168,6 +6984,7 @@
           <a:lstStyle xmlns:a="http://schemas.openxmlformats.org/drawingml/2006/main"/>
           <a:p xmlns:a="http://schemas.openxmlformats.org/drawingml/2006/main">
             <a:pPr algn="l">
+              <a:buNone/>
               <a:defRPr sz="975" b="0" i="0">
                 <a:solidFill>
                   <a:srgbClr val="232E26"/>
@@ -7226,6 +7043,7 @@
           <a:lstStyle xmlns:a="http://schemas.openxmlformats.org/drawingml/2006/main"/>
           <a:p xmlns:a="http://schemas.openxmlformats.org/drawingml/2006/main">
             <a:pPr algn="r">
+              <a:buNone/>
               <a:defRPr sz="975" b="0" i="0">
                 <a:solidFill>
                   <a:srgbClr val="232E26"/>
@@ -7317,6 +7135,7 @@
           <a:lstStyle xmlns:a="http://schemas.openxmlformats.org/drawingml/2006/main"/>
           <a:p xmlns:a="http://schemas.openxmlformats.org/drawingml/2006/main">
             <a:pPr algn="l">
+              <a:buNone/>
               <a:defRPr sz="750" b="0" i="0">
                 <a:solidFill>
                   <a:srgbClr val="232E26">
@@ -7379,6 +7198,7 @@
           <a:lstStyle xmlns:a="http://schemas.openxmlformats.org/drawingml/2006/main"/>
           <a:p xmlns:a="http://schemas.openxmlformats.org/drawingml/2006/main">
             <a:pPr algn="l">
+              <a:buNone/>
               <a:defRPr sz="3600" b="1" i="0">
                 <a:solidFill>
                   <a:srgbClr val="232E26"/>
@@ -7437,6 +7257,7 @@
           <a:lstStyle xmlns:a="http://schemas.openxmlformats.org/drawingml/2006/main"/>
           <a:p xmlns:a="http://schemas.openxmlformats.org/drawingml/2006/main">
             <a:pPr algn="l">
+              <a:buNone/>
               <a:defRPr sz="1425" b="0" i="0">
                 <a:solidFill>
                   <a:srgbClr val="1E2820"/>
@@ -7462,7 +7283,7 @@
       </p:sp>
       <p:graphicFrame>
         <p:nvGraphicFramePr>
-          <p:cNvPr id="17" name="mat-editable-session-column-chart"/>
+          <p:cNvPr id="20" name="mat-editable-session-column-chart"/>
           <p:cNvGraphicFramePr/>
           <p:nvPr/>
         </p:nvGraphicFramePr>
@@ -7472,7 +7293,7 @@
         </p:xfrm>
         <a:graphic xmlns:a="http://schemas.openxmlformats.org/drawingml/2006/main">
           <a:graphicData uri="http://schemas.openxmlformats.org/drawingml/2006/chart">
-            <c:chart xmlns:r="http://schemas.openxmlformats.org/officeDocument/2006/relationships" xmlns:c="http://schemas.openxmlformats.org/drawingml/2006/chart" r:id="Rbe31ff63ac3f4724"/>
+            <c:chart xmlns:r="http://schemas.openxmlformats.org/officeDocument/2006/relationships" xmlns:c="http://schemas.openxmlformats.org/drawingml/2006/chart" r:id="R207089d9fc4744c7"/>
           </a:graphicData>
         </a:graphic>
       </p:graphicFrame>
@@ -7511,6 +7332,7 @@
           <a:lstStyle xmlns:a="http://schemas.openxmlformats.org/drawingml/2006/main"/>
           <a:p xmlns:a="http://schemas.openxmlformats.org/drawingml/2006/main">
             <a:pPr algn="l">
+              <a:buNone/>
               <a:defRPr sz="825" b="0" i="0">
                 <a:solidFill>
                   <a:srgbClr val="C07030"/>
@@ -7549,9 +7371,23 @@
   <p:cSld>
     <p:bg>
       <p:bgPr>
-        <a:solidFill xmlns:a="http://schemas.openxmlformats.org/drawingml/2006/main">
-          <a:srgbClr val="232E26"/>
-        </a:solidFill>
+        <a:gradFill xmlns:a="http://schemas.openxmlformats.org/drawingml/2006/main">
+          <a:gsLst>
+            <a:gs pos="0">
+              <a:srgbClr val="232E26"/>
+            </a:gs>
+            <a:gs pos="56000">
+              <a:srgbClr val="232E26"/>
+            </a:gs>
+            <a:gs pos="78000">
+              <a:srgbClr val="2B3026"/>
+            </a:gs>
+            <a:gs pos="100000">
+              <a:srgbClr val="514029"/>
+            </a:gs>
+          </a:gsLst>
+          <a:lin ang="2700000"/>
+        </a:gradFill>
       </p:bgPr>
     </p:bg>
     <p:spTree>
@@ -7565,54 +7401,6 @@
       </p:grpSpPr>
       <p:sp>
         <p:nvSpPr>
-          <p:cNvPr id="1" name="mat-ledger-wood-glow">
-            <a:extLst xmlns:a="http://schemas.openxmlformats.org/drawingml/2006/main">
-              <a:ext uri="{FF2B5EF4-FFF2-40B4-BE49-F238E27FC236}">
-                <a16:creationId xmlns:a16="http://schemas.microsoft.com/office/drawing/2014/main" id="{B20F6799-C209-415D-A27C-0BCAA1E807F7}"/>
-              </a:ext>
-            </a:extLst>
-          </p:cNvPr>
-          <p:cNvSpPr>
-            <a:spLocks xmlns:a="http://schemas.openxmlformats.org/drawingml/2006/main" noGrp="1"/>
-          </p:cNvSpPr>
-          <p:nvPr/>
-        </p:nvSpPr>
-        <p:spPr>
-          <a:xfrm xmlns:a="http://schemas.openxmlformats.org/drawingml/2006/main">
-            <a:off x="7810500" y="3371850"/>
-            <a:ext cx="4324350" cy="3276600"/>
-          </a:xfrm>
-          <a:prstGeom xmlns:a="http://schemas.openxmlformats.org/drawingml/2006/main" prst="ellipse">
-            <a:avLst/>
-          </a:prstGeom>
-          <a:gradFill xmlns:a="http://schemas.openxmlformats.org/drawingml/2006/main">
-            <a:gsLst>
-              <a:gs pos="0">
-                <a:srgbClr val="7A4E24">
-                  <a:alpha val="34000"/>
-                </a:srgbClr>
-              </a:gs>
-              <a:gs pos="46000">
-                <a:srgbClr val="7A4E24">
-                  <a:alpha val="14000"/>
-                </a:srgbClr>
-              </a:gs>
-              <a:gs pos="100000">
-                <a:srgbClr val="232E26">
-                  <a:alpha val="0"/>
-                </a:srgbClr>
-              </a:gs>
-            </a:gsLst>
-            <a:path path="shape"/>
-          </a:gradFill>
-          <a:ln xmlns:a="http://schemas.openxmlformats.org/drawingml/2006/main" w="0">
-            <a:noFill/>
-            <a:prstDash val="solid"/>
-          </a:ln>
-        </p:spPr>
-      </p:sp>
-      <p:sp>
-        <p:nvSpPr>
           <p:cNvPr id="2" name="mat-top-rule-7">
             <a:extLst xmlns:a="http://schemas.openxmlformats.org/drawingml/2006/main">
               <a:ext uri="{FF2B5EF4-FFF2-40B4-BE49-F238E27FC236}">
@@ -7679,6 +7467,7 @@
           <a:lstStyle xmlns:a="http://schemas.openxmlformats.org/drawingml/2006/main"/>
           <a:p xmlns:a="http://schemas.openxmlformats.org/drawingml/2006/main">
             <a:pPr algn="l">
+              <a:buNone/>
               <a:defRPr sz="975" b="0" i="0">
                 <a:solidFill>
                   <a:srgbClr val="F0E8D2"/>
@@ -7737,6 +7526,7 @@
           <a:lstStyle xmlns:a="http://schemas.openxmlformats.org/drawingml/2006/main"/>
           <a:p xmlns:a="http://schemas.openxmlformats.org/drawingml/2006/main">
             <a:pPr algn="r">
+              <a:buNone/>
               <a:defRPr sz="975" b="0" i="0">
                 <a:solidFill>
                   <a:srgbClr val="F0E8D2"/>
@@ -7828,6 +7618,7 @@
           <a:lstStyle xmlns:a="http://schemas.openxmlformats.org/drawingml/2006/main"/>
           <a:p xmlns:a="http://schemas.openxmlformats.org/drawingml/2006/main">
             <a:pPr algn="l">
+              <a:buNone/>
               <a:defRPr sz="750" b="0" i="0">
                 <a:solidFill>
                   <a:srgbClr val="F0E8D2">
@@ -7890,6 +7681,7 @@
           <a:lstStyle xmlns:a="http://schemas.openxmlformats.org/drawingml/2006/main"/>
           <a:p xmlns:a="http://schemas.openxmlformats.org/drawingml/2006/main">
             <a:pPr algn="l">
+              <a:buNone/>
               <a:defRPr sz="3675" b="1" i="0">
                 <a:solidFill>
                   <a:srgbClr val="F0E8D2"/>
@@ -7948,6 +7740,7 @@
           <a:lstStyle xmlns:a="http://schemas.openxmlformats.org/drawingml/2006/main"/>
           <a:p xmlns:a="http://schemas.openxmlformats.org/drawingml/2006/main">
             <a:pPr algn="l">
+              <a:buNone/>
               <a:defRPr sz="1425" b="0" i="0">
                 <a:solidFill>
                   <a:srgbClr val="F0E8D2">
@@ -8002,7 +7795,9 @@
                     <a:bodyPr lIns="104775" tIns="57150" rIns="104775" bIns="57150" anchor="ctr"/>
                     <a:lstStyle/>
                     <a:p>
-                      <a:pPr algn="l"/>
+                      <a:pPr algn="l">
+                        <a:buNone/>
+                      </a:pPr>
                       <a:r>
                         <a:rPr sz="1125" b="1">
                           <a:solidFill>
@@ -8027,7 +7822,9 @@
                     <a:bodyPr lIns="104775" tIns="57150" rIns="104775" bIns="57150" anchor="ctr"/>
                     <a:lstStyle/>
                     <a:p>
-                      <a:pPr algn="ctr"/>
+                      <a:pPr algn="ctr">
+                        <a:buNone/>
+                      </a:pPr>
                       <a:r>
                         <a:rPr sz="1125" b="1">
                           <a:solidFill>
@@ -8052,7 +7849,9 @@
                     <a:bodyPr lIns="104775" tIns="57150" rIns="104775" bIns="57150" anchor="ctr"/>
                     <a:lstStyle/>
                     <a:p>
-                      <a:pPr algn="ctr"/>
+                      <a:pPr algn="ctr">
+                        <a:buNone/>
+                      </a:pPr>
                       <a:r>
                         <a:rPr sz="1125" b="1">
                           <a:solidFill>
@@ -8077,7 +7876,9 @@
                     <a:bodyPr lIns="104775" tIns="57150" rIns="104775" bIns="57150" anchor="ctr"/>
                     <a:lstStyle/>
                     <a:p>
-                      <a:pPr algn="ctr"/>
+                      <a:pPr algn="ctr">
+                        <a:buNone/>
+                      </a:pPr>
                       <a:r>
                         <a:rPr sz="1125" b="1">
                           <a:solidFill>
@@ -8102,7 +7903,9 @@
                     <a:bodyPr lIns="104775" tIns="57150" rIns="104775" bIns="57150" anchor="ctr"/>
                     <a:lstStyle/>
                     <a:p>
-                      <a:pPr algn="l"/>
+                      <a:pPr algn="l">
+                        <a:buNone/>
+                      </a:pPr>
                       <a:r>
                         <a:rPr sz="1125" b="1">
                           <a:solidFill>
@@ -8129,7 +7932,9 @@
                     <a:bodyPr lIns="104775" tIns="57150" rIns="104775" bIns="57150" anchor="ctr"/>
                     <a:lstStyle/>
                     <a:p>
-                      <a:pPr algn="l"/>
+                      <a:pPr algn="l">
+                        <a:buNone/>
+                      </a:pPr>
                       <a:r>
                         <a:rPr sz="1425" b="1">
                           <a:solidFill>
@@ -8154,7 +7959,9 @@
                     <a:bodyPr lIns="104775" tIns="57150" rIns="104775" bIns="57150" anchor="ctr"/>
                     <a:lstStyle/>
                     <a:p>
-                      <a:pPr algn="ctr"/>
+                      <a:pPr algn="ctr">
+                        <a:buNone/>
+                      </a:pPr>
                       <a:r>
                         <a:rPr sz="1275" b="0">
                           <a:solidFill>
@@ -8179,7 +7986,9 @@
                     <a:bodyPr lIns="104775" tIns="57150" rIns="104775" bIns="57150" anchor="ctr"/>
                     <a:lstStyle/>
                     <a:p>
-                      <a:pPr algn="ctr"/>
+                      <a:pPr algn="ctr">
+                        <a:buNone/>
+                      </a:pPr>
                       <a:r>
                         <a:rPr sz="1275" b="0">
                           <a:solidFill>
@@ -8204,7 +8013,9 @@
                     <a:bodyPr lIns="104775" tIns="57150" rIns="104775" bIns="57150" anchor="ctr"/>
                     <a:lstStyle/>
                     <a:p>
-                      <a:pPr algn="ctr"/>
+                      <a:pPr algn="ctr">
+                        <a:buNone/>
+                      </a:pPr>
                       <a:r>
                         <a:rPr sz="1275" b="0">
                           <a:solidFill>
@@ -8229,7 +8040,9 @@
                     <a:bodyPr lIns="104775" tIns="57150" rIns="104775" bIns="57150" anchor="ctr"/>
                     <a:lstStyle/>
                     <a:p>
-                      <a:pPr algn="l"/>
+                      <a:pPr algn="l">
+                        <a:buNone/>
+                      </a:pPr>
                       <a:r>
                         <a:rPr sz="1275" b="0">
                           <a:solidFill>
@@ -8256,7 +8069,9 @@
                     <a:bodyPr lIns="104775" tIns="57150" rIns="104775" bIns="57150" anchor="ctr"/>
                     <a:lstStyle/>
                     <a:p>
-                      <a:pPr algn="l"/>
+                      <a:pPr algn="l">
+                        <a:buNone/>
+                      </a:pPr>
                       <a:r>
                         <a:rPr sz="1425" b="1">
                           <a:solidFill>
@@ -8281,7 +8096,9 @@
                     <a:bodyPr lIns="104775" tIns="57150" rIns="104775" bIns="57150" anchor="ctr"/>
                     <a:lstStyle/>
                     <a:p>
-                      <a:pPr algn="ctr"/>
+                      <a:pPr algn="ctr">
+                        <a:buNone/>
+                      </a:pPr>
                       <a:r>
                         <a:rPr sz="1275" b="0">
                           <a:solidFill>
@@ -8306,7 +8123,9 @@
                     <a:bodyPr lIns="104775" tIns="57150" rIns="104775" bIns="57150" anchor="ctr"/>
                     <a:lstStyle/>
                     <a:p>
-                      <a:pPr algn="ctr"/>
+                      <a:pPr algn="ctr">
+                        <a:buNone/>
+                      </a:pPr>
                       <a:r>
                         <a:rPr sz="1275" b="0">
                           <a:solidFill>
@@ -8331,7 +8150,9 @@
                     <a:bodyPr lIns="104775" tIns="57150" rIns="104775" bIns="57150" anchor="ctr"/>
                     <a:lstStyle/>
                     <a:p>
-                      <a:pPr algn="ctr"/>
+                      <a:pPr algn="ctr">
+                        <a:buNone/>
+                      </a:pPr>
                       <a:r>
                         <a:rPr sz="1275" b="0">
                           <a:solidFill>
@@ -8356,7 +8177,9 @@
                     <a:bodyPr lIns="104775" tIns="57150" rIns="104775" bIns="57150" anchor="ctr"/>
                     <a:lstStyle/>
                     <a:p>
-                      <a:pPr algn="l"/>
+                      <a:pPr algn="l">
+                        <a:buNone/>
+                      </a:pPr>
                       <a:r>
                         <a:rPr sz="1275" b="0">
                           <a:solidFill>
@@ -8383,7 +8206,9 @@
                     <a:bodyPr lIns="104775" tIns="57150" rIns="104775" bIns="57150" anchor="ctr"/>
                     <a:lstStyle/>
                     <a:p>
-                      <a:pPr algn="l"/>
+                      <a:pPr algn="l">
+                        <a:buNone/>
+                      </a:pPr>
                       <a:r>
                         <a:rPr sz="1425" b="1">
                           <a:solidFill>
@@ -8408,7 +8233,9 @@
                     <a:bodyPr lIns="104775" tIns="57150" rIns="104775" bIns="57150" anchor="ctr"/>
                     <a:lstStyle/>
                     <a:p>
-                      <a:pPr algn="ctr"/>
+                      <a:pPr algn="ctr">
+                        <a:buNone/>
+                      </a:pPr>
                       <a:r>
                         <a:rPr sz="1275" b="0">
                           <a:solidFill>
@@ -8433,7 +8260,9 @@
                     <a:bodyPr lIns="104775" tIns="57150" rIns="104775" bIns="57150" anchor="ctr"/>
                     <a:lstStyle/>
                     <a:p>
-                      <a:pPr algn="ctr"/>
+                      <a:pPr algn="ctr">
+                        <a:buNone/>
+                      </a:pPr>
                       <a:r>
                         <a:rPr sz="1275" b="0">
                           <a:solidFill>
@@ -8458,7 +8287,9 @@
                     <a:bodyPr lIns="104775" tIns="57150" rIns="104775" bIns="57150" anchor="ctr"/>
                     <a:lstStyle/>
                     <a:p>
-                      <a:pPr algn="ctr"/>
+                      <a:pPr algn="ctr">
+                        <a:buNone/>
+                      </a:pPr>
                       <a:r>
                         <a:rPr sz="1275" b="0">
                           <a:solidFill>
@@ -8483,7 +8314,9 @@
                     <a:bodyPr lIns="104775" tIns="57150" rIns="104775" bIns="57150" anchor="ctr"/>
                     <a:lstStyle/>
                     <a:p>
-                      <a:pPr algn="l"/>
+                      <a:pPr algn="l">
+                        <a:buNone/>
+                      </a:pPr>
                       <a:r>
                         <a:rPr sz="1275" b="0">
                           <a:solidFill>
@@ -8510,7 +8343,9 @@
                     <a:bodyPr lIns="104775" tIns="57150" rIns="104775" bIns="57150" anchor="ctr"/>
                     <a:lstStyle/>
                     <a:p>
-                      <a:pPr algn="l"/>
+                      <a:pPr algn="l">
+                        <a:buNone/>
+                      </a:pPr>
                       <a:r>
                         <a:rPr sz="1425" b="1">
                           <a:solidFill>
@@ -8535,7 +8370,9 @@
                     <a:bodyPr lIns="104775" tIns="57150" rIns="104775" bIns="57150" anchor="ctr"/>
                     <a:lstStyle/>
                     <a:p>
-                      <a:pPr algn="ctr"/>
+                      <a:pPr algn="ctr">
+                        <a:buNone/>
+                      </a:pPr>
                       <a:r>
                         <a:rPr sz="1275" b="0">
                           <a:solidFill>
@@ -8560,7 +8397,9 @@
                     <a:bodyPr lIns="104775" tIns="57150" rIns="104775" bIns="57150" anchor="ctr"/>
                     <a:lstStyle/>
                     <a:p>
-                      <a:pPr algn="ctr"/>
+                      <a:pPr algn="ctr">
+                        <a:buNone/>
+                      </a:pPr>
                       <a:r>
                         <a:rPr sz="1275" b="0">
                           <a:solidFill>
@@ -8585,7 +8424,9 @@
                     <a:bodyPr lIns="104775" tIns="57150" rIns="104775" bIns="57150" anchor="ctr"/>
                     <a:lstStyle/>
                     <a:p>
-                      <a:pPr algn="ctr"/>
+                      <a:pPr algn="ctr">
+                        <a:buNone/>
+                      </a:pPr>
                       <a:r>
                         <a:rPr sz="1275" b="0">
                           <a:solidFill>
@@ -8610,7 +8451,9 @@
                     <a:bodyPr lIns="104775" tIns="57150" rIns="104775" bIns="57150" anchor="ctr"/>
                     <a:lstStyle/>
                     <a:p>
-                      <a:pPr algn="l"/>
+                      <a:pPr algn="l">
+                        <a:buNone/>
+                      </a:pPr>
                       <a:r>
                         <a:rPr sz="1275" b="0">
                           <a:solidFill>
@@ -8637,7 +8480,9 @@
                     <a:bodyPr lIns="104775" tIns="57150" rIns="104775" bIns="57150" anchor="ctr"/>
                     <a:lstStyle/>
                     <a:p>
-                      <a:pPr algn="l"/>
+                      <a:pPr algn="l">
+                        <a:buNone/>
+                      </a:pPr>
                       <a:r>
                         <a:rPr sz="1425" b="1">
                           <a:solidFill>
@@ -8662,7 +8507,9 @@
                     <a:bodyPr lIns="104775" tIns="57150" rIns="104775" bIns="57150" anchor="ctr"/>
                     <a:lstStyle/>
                     <a:p>
-                      <a:pPr algn="ctr"/>
+                      <a:pPr algn="ctr">
+                        <a:buNone/>
+                      </a:pPr>
                       <a:r>
                         <a:rPr sz="1275" b="0">
                           <a:solidFill>
@@ -8687,7 +8534,9 @@
                     <a:bodyPr lIns="104775" tIns="57150" rIns="104775" bIns="57150" anchor="ctr"/>
                     <a:lstStyle/>
                     <a:p>
-                      <a:pPr algn="ctr"/>
+                      <a:pPr algn="ctr">
+                        <a:buNone/>
+                      </a:pPr>
                       <a:r>
                         <a:rPr sz="1275" b="0">
                           <a:solidFill>
@@ -8712,7 +8561,9 @@
                     <a:bodyPr lIns="104775" tIns="57150" rIns="104775" bIns="57150" anchor="ctr"/>
                     <a:lstStyle/>
                     <a:p>
-                      <a:pPr algn="ctr"/>
+                      <a:pPr algn="ctr">
+                        <a:buNone/>
+                      </a:pPr>
                       <a:r>
                         <a:rPr sz="1275" b="0">
                           <a:solidFill>
@@ -8737,7 +8588,9 @@
                     <a:bodyPr lIns="104775" tIns="57150" rIns="104775" bIns="57150" anchor="ctr"/>
                     <a:lstStyle/>
                     <a:p>
-                      <a:pPr algn="l"/>
+                      <a:pPr algn="l">
+                        <a:buNone/>
+                      </a:pPr>
                       <a:r>
                         <a:rPr sz="1275" b="0">
                           <a:solidFill>
@@ -8797,6 +8650,7 @@
           <a:lstStyle xmlns:a="http://schemas.openxmlformats.org/drawingml/2006/main"/>
           <a:p xmlns:a="http://schemas.openxmlformats.org/drawingml/2006/main">
             <a:pPr algn="l">
+              <a:buNone/>
               <a:defRPr sz="825" b="0" i="0">
                 <a:solidFill>
                   <a:srgbClr val="C07030"/>
@@ -8835,9 +8689,23 @@
   <p:cSld>
     <p:bg>
       <p:bgPr>
-        <a:solidFill xmlns:a="http://schemas.openxmlformats.org/drawingml/2006/main">
-          <a:srgbClr val="232E26"/>
-        </a:solidFill>
+        <a:gradFill xmlns:a="http://schemas.openxmlformats.org/drawingml/2006/main">
+          <a:gsLst>
+            <a:gs pos="0">
+              <a:srgbClr val="232E26"/>
+            </a:gs>
+            <a:gs pos="56000">
+              <a:srgbClr val="232E26"/>
+            </a:gs>
+            <a:gs pos="78000">
+              <a:srgbClr val="2B3026"/>
+            </a:gs>
+            <a:gs pos="100000">
+              <a:srgbClr val="514029"/>
+            </a:gs>
+          </a:gsLst>
+          <a:lin ang="2700000"/>
+        </a:gradFill>
       </p:bgPr>
     </p:bg>
     <p:spTree>
@@ -8851,54 +8719,6 @@
       </p:grpSpPr>
       <p:sp>
         <p:nvSpPr>
-          <p:cNvPr id="1" name="mat-close-wood-glow">
-            <a:extLst xmlns:a="http://schemas.openxmlformats.org/drawingml/2006/main">
-              <a:ext uri="{FF2B5EF4-FFF2-40B4-BE49-F238E27FC236}">
-                <a16:creationId xmlns:a16="http://schemas.microsoft.com/office/drawing/2014/main" id="{B1779D63-530C-4F3D-9768-B41D22667BBC}"/>
-              </a:ext>
-            </a:extLst>
-          </p:cNvPr>
-          <p:cNvSpPr>
-            <a:spLocks xmlns:a="http://schemas.openxmlformats.org/drawingml/2006/main" noGrp="1"/>
-          </p:cNvSpPr>
-          <p:nvPr/>
-        </p:nvSpPr>
-        <p:spPr>
-          <a:xfrm xmlns:a="http://schemas.openxmlformats.org/drawingml/2006/main">
-            <a:off x="7810500" y="3371850"/>
-            <a:ext cx="4324350" cy="3276600"/>
-          </a:xfrm>
-          <a:prstGeom xmlns:a="http://schemas.openxmlformats.org/drawingml/2006/main" prst="ellipse">
-            <a:avLst/>
-          </a:prstGeom>
-          <a:gradFill xmlns:a="http://schemas.openxmlformats.org/drawingml/2006/main">
-            <a:gsLst>
-              <a:gs pos="0">
-                <a:srgbClr val="7A4E24">
-                  <a:alpha val="34000"/>
-                </a:srgbClr>
-              </a:gs>
-              <a:gs pos="46000">
-                <a:srgbClr val="7A4E24">
-                  <a:alpha val="14000"/>
-                </a:srgbClr>
-              </a:gs>
-              <a:gs pos="100000">
-                <a:srgbClr val="232E26">
-                  <a:alpha val="0"/>
-                </a:srgbClr>
-              </a:gs>
-            </a:gsLst>
-            <a:path path="shape"/>
-          </a:gradFill>
-          <a:ln xmlns:a="http://schemas.openxmlformats.org/drawingml/2006/main" w="0">
-            <a:noFill/>
-            <a:prstDash val="solid"/>
-          </a:ln>
-        </p:spPr>
-      </p:sp>
-      <p:sp>
-        <p:nvSpPr>
           <p:cNvPr id="2" name="mat-close-kicker">
             <a:extLst xmlns:a="http://schemas.openxmlformats.org/drawingml/2006/main">
               <a:ext uri="{FF2B5EF4-FFF2-40B4-BE49-F238E27FC236}">
@@ -8932,6 +8752,7 @@
           <a:lstStyle xmlns:a="http://schemas.openxmlformats.org/drawingml/2006/main"/>
           <a:p xmlns:a="http://schemas.openxmlformats.org/drawingml/2006/main">
             <a:pPr algn="l">
+              <a:buNone/>
               <a:defRPr sz="1050" b="0" i="0">
                 <a:solidFill>
                   <a:srgbClr val="C07030"/>
@@ -8990,6 +8811,7 @@
           <a:lstStyle xmlns:a="http://schemas.openxmlformats.org/drawingml/2006/main"/>
           <a:p xmlns:a="http://schemas.openxmlformats.org/drawingml/2006/main">
             <a:pPr algn="l">
+              <a:buNone/>
               <a:defRPr sz="6150" b="1" i="0">
                 <a:solidFill>
                   <a:srgbClr val="F0E8D2"/>
@@ -9048,6 +8870,7 @@
           <a:lstStyle xmlns:a="http://schemas.openxmlformats.org/drawingml/2006/main"/>
           <a:p xmlns:a="http://schemas.openxmlformats.org/drawingml/2006/main">
             <a:pPr algn="l">
+              <a:buNone/>
               <a:defRPr sz="6150" b="1" i="0">
                 <a:solidFill>
                   <a:srgbClr val="C07030"/>
@@ -9137,6 +8960,7 @@
           <a:lstStyle xmlns:a="http://schemas.openxmlformats.org/drawingml/2006/main"/>
           <a:p xmlns:a="http://schemas.openxmlformats.org/drawingml/2006/main">
             <a:pPr algn="l">
+              <a:buNone/>
               <a:defRPr sz="975" b="0" i="0">
                 <a:solidFill>
                   <a:srgbClr val="C07030"/>
@@ -9195,6 +9019,7 @@
           <a:lstStyle xmlns:a="http://schemas.openxmlformats.org/drawingml/2006/main"/>
           <a:p xmlns:a="http://schemas.openxmlformats.org/drawingml/2006/main">
             <a:pPr algn="l">
+              <a:buNone/>
               <a:defRPr sz="1800" b="1" i="0">
                 <a:solidFill>
                   <a:srgbClr val="232E26"/>
@@ -9348,6 +9173,7 @@
           <a:lstStyle xmlns:a="http://schemas.openxmlformats.org/drawingml/2006/main"/>
           <a:p xmlns:a="http://schemas.openxmlformats.org/drawingml/2006/main">
             <a:pPr algn="l">
+              <a:buNone/>
               <a:defRPr sz="975" b="0" i="0">
                 <a:solidFill>
                   <a:srgbClr val="C07030"/>
@@ -9406,6 +9232,7 @@
           <a:lstStyle xmlns:a="http://schemas.openxmlformats.org/drawingml/2006/main"/>
           <a:p xmlns:a="http://schemas.openxmlformats.org/drawingml/2006/main">
             <a:pPr algn="l">
+              <a:buNone/>
               <a:defRPr sz="1800" b="1" i="0">
                 <a:solidFill>
                   <a:srgbClr val="232E26"/>
@@ -9559,6 +9386,7 @@
           <a:lstStyle xmlns:a="http://schemas.openxmlformats.org/drawingml/2006/main"/>
           <a:p xmlns:a="http://schemas.openxmlformats.org/drawingml/2006/main">
             <a:pPr algn="l">
+              <a:buNone/>
               <a:defRPr sz="975" b="0" i="0">
                 <a:solidFill>
                   <a:srgbClr val="C07030"/>
@@ -9617,6 +9445,7 @@
           <a:lstStyle xmlns:a="http://schemas.openxmlformats.org/drawingml/2006/main"/>
           <a:p xmlns:a="http://schemas.openxmlformats.org/drawingml/2006/main">
             <a:pPr algn="l">
+              <a:buNone/>
               <a:defRPr sz="1800" b="1" i="0">
                 <a:solidFill>
                   <a:srgbClr val="232E26"/>
@@ -9737,6 +9566,7 @@
           <a:lstStyle xmlns:a="http://schemas.openxmlformats.org/drawingml/2006/main"/>
           <a:p xmlns:a="http://schemas.openxmlformats.org/drawingml/2006/main">
             <a:pPr algn="l">
+              <a:buNone/>
               <a:defRPr sz="900" b="0" i="0">
                 <a:solidFill>
                   <a:srgbClr val="F0E8D2">

</xml_diff>

<commit_message>
chore(pptx): update demo slide (#49)
* chore(pptx): update demo slide

* chore: update remotion config
</commit_message>
<xml_diff>
--- a/apps/docs/public/assets/after-the-needle-drops-mat.pptx
+++ b/apps/docs/public/assets/after-the-needle-drops-mat.pptx
@@ -1,137 +1,42 @@
 
 <file path=ppt/presentation.xml><?xml version="1.0" encoding="utf-8"?>
-<p:presentation xmlns:r="http://schemas.openxmlformats.org/officeDocument/2006/relationships" xmlns:p="http://schemas.openxmlformats.org/presentationml/2006/main" saveSubsetFonts="false" embedTrueTypeFonts="true">
+<p:presentation xmlns:p="http://schemas.openxmlformats.org/presentationml/2006/main" embedTrueTypeFonts="1" saveSubsetFonts="0">
   <p:sldMasterIdLst>
-    <p:sldMasterId xmlns:r="http://schemas.openxmlformats.org/officeDocument/2006/relationships" id="2147483648" r:id="R0cd65d591a6a48af"/>
+    <p:sldMasterId xmlns:r="http://schemas.openxmlformats.org/officeDocument/2006/relationships" id="2147483648" r:id="R985fffaa8ecf4e64"/>
   </p:sldMasterIdLst>
   <p:notesMasterIdLst>
-    <p:notesMasterId xmlns:r="http://schemas.openxmlformats.org/officeDocument/2006/relationships" r:id="Rdeb84743a7c14ac1"/>
+    <p:notesMasterId xmlns:r="http://schemas.openxmlformats.org/officeDocument/2006/relationships" r:id="Rf0b747b4d25348b3"/>
   </p:notesMasterIdLst>
   <p:sldIdLst>
-    <p:sldId xmlns:r="http://schemas.openxmlformats.org/officeDocument/2006/relationships" id="256" r:id="R38cf979c59fc486c"/>
-    <p:sldId xmlns:r="http://schemas.openxmlformats.org/officeDocument/2006/relationships" id="257" r:id="Ra9bd7656bfb248b6"/>
-    <p:sldId xmlns:r="http://schemas.openxmlformats.org/officeDocument/2006/relationships" id="258" r:id="R7018436128384cc3"/>
-    <p:sldId xmlns:r="http://schemas.openxmlformats.org/officeDocument/2006/relationships" id="259" r:id="Ra2622099ae7c4920"/>
-    <p:sldId xmlns:r="http://schemas.openxmlformats.org/officeDocument/2006/relationships" id="260" r:id="R4bcd86a7e9804207"/>
-    <p:sldId xmlns:r="http://schemas.openxmlformats.org/officeDocument/2006/relationships" id="261" r:id="R3b753bd8b7fd4b4e"/>
-    <p:sldId xmlns:r="http://schemas.openxmlformats.org/officeDocument/2006/relationships" id="262" r:id="R53d0c15f54434ccb"/>
-    <p:sldId xmlns:r="http://schemas.openxmlformats.org/officeDocument/2006/relationships" id="263" r:id="R4ac4c32fe08748a9"/>
+    <p:sldId xmlns:r="http://schemas.openxmlformats.org/officeDocument/2006/relationships" id="256" r:id="Radc888fd38d04a0c"/>
+    <p:sldId xmlns:r="http://schemas.openxmlformats.org/officeDocument/2006/relationships" id="257" r:id="Rf529acfa66c94849"/>
+    <p:sldId xmlns:r="http://schemas.openxmlformats.org/officeDocument/2006/relationships" id="258" r:id="R30850e12c9b54e67"/>
+    <p:sldId xmlns:r="http://schemas.openxmlformats.org/officeDocument/2006/relationships" id="259" r:id="R44736552453f444e"/>
+    <p:sldId xmlns:r="http://schemas.openxmlformats.org/officeDocument/2006/relationships" id="260" r:id="Rf7a10974ad6a46b1"/>
+    <p:sldId xmlns:r="http://schemas.openxmlformats.org/officeDocument/2006/relationships" id="261" r:id="Rd0a0af7e0af04493"/>
+    <p:sldId xmlns:r="http://schemas.openxmlformats.org/officeDocument/2006/relationships" id="262" r:id="Rda21e34d44714bbf"/>
+    <p:sldId xmlns:r="http://schemas.openxmlformats.org/officeDocument/2006/relationships" id="263" r:id="Rb45fb6cc69704596"/>
   </p:sldIdLst>
   <p:sldSz cx="12192000" cy="6858000"/>
   <p:notesSz cx="6858000" cy="9144000"/>
   <p:embeddedFontLst>
     <p:embeddedFont>
       <p:font typeface="Bricolage Grotesque Display"/>
-      <p:regular r:id="rId201314"/>
+      <p:regular xmlns:r="http://schemas.openxmlformats.org/officeDocument/2006/relationships" r:id="Ra3888ce39a4c480c"/>
     </p:embeddedFont>
     <p:embeddedFont>
       <p:font typeface="Bricolage Grotesque Heading"/>
-      <p:regular r:id="rId201315"/>
+      <p:regular xmlns:r="http://schemas.openxmlformats.org/officeDocument/2006/relationships" r:id="R09480e41c8d248b8"/>
     </p:embeddedFont>
     <p:embeddedFont>
       <p:font typeface="DM Sans Text"/>
-      <p:regular r:id="rId201316"/>
+      <p:regular xmlns:r="http://schemas.openxmlformats.org/officeDocument/2006/relationships" r:id="R2fcbe9ac7db743ec"/>
     </p:embeddedFont>
     <p:embeddedFont>
       <p:font typeface="DM Mono Labels"/>
-      <p:regular r:id="rId201317"/>
+      <p:regular xmlns:r="http://schemas.openxmlformats.org/officeDocument/2006/relationships" r:id="R26c7882d1aca4fe0"/>
     </p:embeddedFont>
   </p:embeddedFontLst>
-  <p:defaultTextStyle>
-    <a:defPPr xmlns:a="http://schemas.openxmlformats.org/drawingml/2006/main">
-      <a:defRPr lang="en-US"/>
-    </a:defPPr>
-    <a:lvl1pPr xmlns:a="http://schemas.openxmlformats.org/drawingml/2006/main" marL="0" indent="0" algn="l" defTabSz="914400">
-      <a:defRPr sz="1800" kern="1200">
-        <a:solidFill>
-          <a:schemeClr val="tx1"/>
-        </a:solidFill>
-        <a:latin typeface="+mn-lt"/>
-        <a:ea typeface="+mn-ea"/>
-        <a:cs typeface="+mn-cs"/>
-      </a:defRPr>
-    </a:lvl1pPr>
-    <a:lvl2pPr xmlns:a="http://schemas.openxmlformats.org/drawingml/2006/main" marL="457200" indent="0" algn="l" defTabSz="914400">
-      <a:defRPr sz="1800" kern="1200">
-        <a:solidFill>
-          <a:schemeClr val="tx1"/>
-        </a:solidFill>
-        <a:latin typeface="+mn-lt"/>
-        <a:ea typeface="+mn-ea"/>
-        <a:cs typeface="+mn-cs"/>
-      </a:defRPr>
-    </a:lvl2pPr>
-    <a:lvl3pPr xmlns:a="http://schemas.openxmlformats.org/drawingml/2006/main" marL="914400" indent="0" algn="l" defTabSz="914400">
-      <a:defRPr sz="1800" kern="1200">
-        <a:solidFill>
-          <a:schemeClr val="tx1"/>
-        </a:solidFill>
-        <a:latin typeface="+mn-lt"/>
-        <a:ea typeface="+mn-ea"/>
-        <a:cs typeface="+mn-cs"/>
-      </a:defRPr>
-    </a:lvl3pPr>
-    <a:lvl4pPr xmlns:a="http://schemas.openxmlformats.org/drawingml/2006/main" marL="1371600" indent="0" algn="l" defTabSz="914400">
-      <a:defRPr sz="1800" kern="1200">
-        <a:solidFill>
-          <a:schemeClr val="tx1"/>
-        </a:solidFill>
-        <a:latin typeface="+mn-lt"/>
-        <a:ea typeface="+mn-ea"/>
-        <a:cs typeface="+mn-cs"/>
-      </a:defRPr>
-    </a:lvl4pPr>
-    <a:lvl5pPr xmlns:a="http://schemas.openxmlformats.org/drawingml/2006/main" marL="1828800" indent="0" algn="l" defTabSz="914400">
-      <a:defRPr sz="1800" kern="1200">
-        <a:solidFill>
-          <a:schemeClr val="tx1"/>
-        </a:solidFill>
-        <a:latin typeface="+mn-lt"/>
-        <a:ea typeface="+mn-ea"/>
-        <a:cs typeface="+mn-cs"/>
-      </a:defRPr>
-    </a:lvl5pPr>
-    <a:lvl6pPr xmlns:a="http://schemas.openxmlformats.org/drawingml/2006/main" marL="2286000" indent="0" algn="l" defTabSz="914400">
-      <a:defRPr sz="1800" kern="1200">
-        <a:solidFill>
-          <a:schemeClr val="tx1"/>
-        </a:solidFill>
-        <a:latin typeface="+mn-lt"/>
-        <a:ea typeface="+mn-ea"/>
-        <a:cs typeface="+mn-cs"/>
-      </a:defRPr>
-    </a:lvl6pPr>
-    <a:lvl7pPr xmlns:a="http://schemas.openxmlformats.org/drawingml/2006/main" marL="2743200" indent="0" algn="l" defTabSz="914400">
-      <a:defRPr sz="1800" kern="1200">
-        <a:solidFill>
-          <a:schemeClr val="tx1"/>
-        </a:solidFill>
-        <a:latin typeface="+mn-lt"/>
-        <a:ea typeface="+mn-ea"/>
-        <a:cs typeface="+mn-cs"/>
-      </a:defRPr>
-    </a:lvl7pPr>
-    <a:lvl8pPr xmlns:a="http://schemas.openxmlformats.org/drawingml/2006/main" marL="3200400" indent="0" algn="l" defTabSz="914400">
-      <a:defRPr sz="1800" kern="1200">
-        <a:solidFill>
-          <a:schemeClr val="tx1"/>
-        </a:solidFill>
-        <a:latin typeface="+mn-lt"/>
-        <a:ea typeface="+mn-ea"/>
-        <a:cs typeface="+mn-cs"/>
-      </a:defRPr>
-    </a:lvl8pPr>
-    <a:lvl9pPr xmlns:a="http://schemas.openxmlformats.org/drawingml/2006/main" marL="3657600" indent="0" algn="l" defTabSz="914400">
-      <a:defRPr sz="1800" kern="1200">
-        <a:solidFill>
-          <a:schemeClr val="tx1"/>
-        </a:solidFill>
-        <a:latin typeface="+mn-lt"/>
-        <a:ea typeface="+mn-ea"/>
-        <a:cs typeface="+mn-cs"/>
-      </a:defRPr>
-    </a:lvl9pPr>
-  </p:defaultTextStyle>
 </p:presentation>
 </file>
 
@@ -1360,7 +1265,7 @@
   </p:cSld>
   <p:clrMap bg1="lt1" tx1="dk1" bg2="lt2" tx2="dk2" accent1="accent1" accent2="accent2" accent3="accent3" accent4="accent4" accent5="accent5" accent6="accent6" hlink="hlink" folHlink="folHlink"/>
   <p:sldLayoutIdLst>
-    <p:sldLayoutId xmlns:r="http://schemas.openxmlformats.org/officeDocument/2006/relationships" id="2147483649" r:id="R35e67c870b2d48d1"/>
+    <p:sldLayoutId xmlns:r="http://schemas.openxmlformats.org/officeDocument/2006/relationships" id="2147483649" r:id="Rbd4c7f0909004e78"/>
   </p:sldLayoutIdLst>
   <p:txStyles>
     <p:titleStyle>
@@ -1894,6 +1799,7 @@
     <c:plotArea>
       <c:lineChart>
         <c:grouping val="standard"/>
+        <c:varyColors val="0"/>
         <c:ser>
           <c:idx val="0"/>
           <c:order val="0"/>
@@ -2051,6 +1957,9 @@
                         <a:alpha val="72000"/>
                       </a:srgbClr>
                     </a:solidFill>
+                    <a:latin typeface="DM Mono Labels"/>
+                    <a:ea typeface="DM Mono Labels"/>
+                    <a:cs typeface="DM Mono Labels"/>
                   </a:rPr>
                   <a:t>OCTAVE BAND · HZ</a:t>
                 </a:r>
@@ -2063,12 +1972,14 @@
             <a:p xmlns:a="http://schemas.openxmlformats.org/drawingml/2006/main">
               <a:pPr>
                 <a:defRPr sz="1275" b="1">
-                  <a:latin typeface="DM Mono Labels"/>
                   <a:solidFill>
                     <a:srgbClr val="F0E8D2">
                       <a:alpha val="72000"/>
                     </a:srgbClr>
                   </a:solidFill>
+                  <a:latin typeface="DM Mono Labels"/>
+                  <a:ea typeface="DM Mono Labels"/>
+                  <a:cs typeface="DM Mono Labels"/>
                 </a:defRPr>
               </a:pPr>
             </a:p>
@@ -2093,18 +2004,18 @@
           <a:p xmlns:a="http://schemas.openxmlformats.org/drawingml/2006/main">
             <a:pPr>
               <a:defRPr sz="1350" b="1">
+                <a:solidFill>
+                  <a:srgbClr val="F0E8D2"/>
+                </a:solidFill>
                 <a:latin typeface="DM Mono Labels"/>
-                <a:solidFill>
-                  <a:srgbClr val="F0E8D2"/>
-                </a:solidFill>
+                <a:ea typeface="DM Mono Labels"/>
+                <a:cs typeface="DM Mono Labels"/>
               </a:defRPr>
             </a:pPr>
           </a:p>
         </c:txPr>
         <c:crossAx val="48672768"/>
-        <c:lblAlgn val="ctr"/>
         <c:lblOffset val="100"/>
-        <c:noMultiLvlLbl val="0"/>
       </c:catAx>
       <c:valAx>
         <c:axId val="48672768"/>
@@ -2140,6 +2051,9 @@
                         <a:alpha val="72000"/>
                       </a:srgbClr>
                     </a:solidFill>
+                    <a:latin typeface="DM Mono Labels"/>
+                    <a:ea typeface="DM Mono Labels"/>
+                    <a:cs typeface="DM Mono Labels"/>
                   </a:rPr>
                   <a:t>DECAY · SECONDS</a:t>
                 </a:r>
@@ -2152,12 +2066,14 @@
             <a:p xmlns:a="http://schemas.openxmlformats.org/drawingml/2006/main">
               <a:pPr>
                 <a:defRPr sz="1275" b="1">
-                  <a:latin typeface="DM Mono Labels"/>
                   <a:solidFill>
                     <a:srgbClr val="F0E8D2">
                       <a:alpha val="72000"/>
                     </a:srgbClr>
                   </a:solidFill>
+                  <a:latin typeface="DM Mono Labels"/>
+                  <a:ea typeface="DM Mono Labels"/>
+                  <a:cs typeface="DM Mono Labels"/>
                 </a:defRPr>
               </a:pPr>
             </a:p>
@@ -2182,10 +2098,12 @@
           <a:p xmlns:a="http://schemas.openxmlformats.org/drawingml/2006/main">
             <a:pPr>
               <a:defRPr sz="1350" b="1">
+                <a:solidFill>
+                  <a:srgbClr val="F0E8D2"/>
+                </a:solidFill>
                 <a:latin typeface="DM Mono Labels"/>
-                <a:solidFill>
-                  <a:srgbClr val="F0E8D2"/>
-                </a:solidFill>
+                <a:ea typeface="DM Mono Labels"/>
+                <a:cs typeface="DM Mono Labels"/>
               </a:defRPr>
             </a:pPr>
           </a:p>
@@ -2219,10 +2137,12 @@
         <a:p xmlns:a="http://schemas.openxmlformats.org/drawingml/2006/main">
           <a:pPr>
             <a:defRPr sz="1350" b="1">
-              <a:latin typeface="DM Mono Labels"/>
               <a:solidFill>
                 <a:srgbClr val="F0E8D2"/>
               </a:solidFill>
+              <a:latin typeface="DM Mono Labels"/>
+              <a:ea typeface="DM Mono Labels"/>
+              <a:cs typeface="DM Mono Labels"/>
             </a:defRPr>
           </a:pPr>
         </a:p>
@@ -2370,10 +2290,12 @@
             <a:p xmlns:a="http://schemas.openxmlformats.org/drawingml/2006/main">
               <a:pPr>
                 <a:defRPr sz="1350" b="1">
-                  <a:latin typeface="DM Mono Labels"/>
                   <a:solidFill>
                     <a:srgbClr val="232E26"/>
                   </a:solidFill>
+                  <a:latin typeface="DM Mono Labels"/>
+                  <a:ea typeface="DM Mono Labels"/>
+                  <a:cs typeface="DM Mono Labels"/>
                 </a:defRPr>
               </a:pPr>
             </a:p>
@@ -2417,18 +2339,18 @@
           <a:p xmlns:a="http://schemas.openxmlformats.org/drawingml/2006/main">
             <a:pPr>
               <a:defRPr sz="1350" b="1">
+                <a:solidFill>
+                  <a:srgbClr val="232E26"/>
+                </a:solidFill>
                 <a:latin typeface="DM Mono Labels"/>
-                <a:solidFill>
-                  <a:srgbClr val="232E26"/>
-                </a:solidFill>
+                <a:ea typeface="DM Mono Labels"/>
+                <a:cs typeface="DM Mono Labels"/>
               </a:defRPr>
             </a:pPr>
           </a:p>
         </c:txPr>
         <c:crossAx val="48672768"/>
-        <c:lblAlgn val="ctr"/>
         <c:lblOffset val="100"/>
-        <c:noMultiLvlLbl val="0"/>
       </c:catAx>
       <c:valAx>
         <c:axId val="48672768"/>
@@ -2464,6 +2386,9 @@
                         <a:alpha val="70000"/>
                       </a:srgbClr>
                     </a:solidFill>
+                    <a:latin typeface="DM Mono Labels"/>
+                    <a:ea typeface="DM Mono Labels"/>
+                    <a:cs typeface="DM Mono Labels"/>
                   </a:rPr>
                   <a:t>UNINTERRUPTED MINUTES</a:t>
                 </a:r>
@@ -2476,12 +2401,14 @@
             <a:p xmlns:a="http://schemas.openxmlformats.org/drawingml/2006/main">
               <a:pPr>
                 <a:defRPr sz="1275" b="1">
-                  <a:latin typeface="DM Mono Labels"/>
                   <a:solidFill>
                     <a:srgbClr val="232E26">
                       <a:alpha val="70000"/>
                     </a:srgbClr>
                   </a:solidFill>
+                  <a:latin typeface="DM Mono Labels"/>
+                  <a:ea typeface="DM Mono Labels"/>
+                  <a:cs typeface="DM Mono Labels"/>
                 </a:defRPr>
               </a:pPr>
             </a:p>
@@ -2506,10 +2433,12 @@
           <a:p xmlns:a="http://schemas.openxmlformats.org/drawingml/2006/main">
             <a:pPr>
               <a:defRPr sz="1350" b="1">
+                <a:solidFill>
+                  <a:srgbClr val="232E26"/>
+                </a:solidFill>
                 <a:latin typeface="DM Mono Labels"/>
-                <a:solidFill>
-                  <a:srgbClr val="232E26"/>
-                </a:solidFill>
+                <a:ea typeface="DM Mono Labels"/>
+                <a:cs typeface="DM Mono Labels"/>
               </a:defRPr>
             </a:pPr>
           </a:p>
@@ -2539,10 +2468,12 @@
         <a:p xmlns:a="http://schemas.openxmlformats.org/drawingml/2006/main">
           <a:pPr>
             <a:defRPr sz="1350" b="1">
-              <a:latin typeface="DM Mono Labels"/>
               <a:solidFill>
                 <a:srgbClr val="232E26"/>
               </a:solidFill>
+              <a:latin typeface="DM Mono Labels"/>
+              <a:ea typeface="DM Mono Labels"/>
+              <a:cs typeface="DM Mono Labels"/>
             </a:defRPr>
           </a:pPr>
         </a:p>
@@ -2569,9 +2500,23 @@
   <p:cSld>
     <p:bg>
       <p:bgPr>
-        <a:solidFill xmlns:a="http://schemas.openxmlformats.org/drawingml/2006/main">
-          <a:srgbClr val="232E26"/>
-        </a:solidFill>
+        <a:gradFill xmlns:a="http://schemas.openxmlformats.org/drawingml/2006/main">
+          <a:gsLst>
+            <a:gs pos="0">
+              <a:srgbClr val="232E26"/>
+            </a:gs>
+            <a:gs pos="56000">
+              <a:srgbClr val="232E26"/>
+            </a:gs>
+            <a:gs pos="78000">
+              <a:srgbClr val="2B3026"/>
+            </a:gs>
+            <a:gs pos="100000">
+              <a:srgbClr val="514029"/>
+            </a:gs>
+          </a:gsLst>
+          <a:lin ang="2700000"/>
+        </a:gradFill>
       </p:bgPr>
     </p:bg>
     <p:spTree>
@@ -2585,54 +2530,6 @@
       </p:grpSpPr>
       <p:sp>
         <p:nvSpPr>
-          <p:cNvPr id="1" name="mat-cover-wood-glow">
-            <a:extLst xmlns:a="http://schemas.openxmlformats.org/drawingml/2006/main">
-              <a:ext uri="{FF2B5EF4-FFF2-40B4-BE49-F238E27FC236}">
-                <a16:creationId xmlns:a16="http://schemas.microsoft.com/office/drawing/2014/main" id="{7F851CA7-7351-40B0-A476-68F295DC779B}"/>
-              </a:ext>
-            </a:extLst>
-          </p:cNvPr>
-          <p:cNvSpPr>
-            <a:spLocks xmlns:a="http://schemas.openxmlformats.org/drawingml/2006/main" noGrp="1"/>
-          </p:cNvSpPr>
-          <p:nvPr/>
-        </p:nvSpPr>
-        <p:spPr>
-          <a:xfrm xmlns:a="http://schemas.openxmlformats.org/drawingml/2006/main">
-            <a:off x="7810500" y="3371850"/>
-            <a:ext cx="4324350" cy="3276600"/>
-          </a:xfrm>
-          <a:prstGeom xmlns:a="http://schemas.openxmlformats.org/drawingml/2006/main" prst="ellipse">
-            <a:avLst/>
-          </a:prstGeom>
-          <a:gradFill xmlns:a="http://schemas.openxmlformats.org/drawingml/2006/main">
-            <a:gsLst>
-              <a:gs pos="0">
-                <a:srgbClr val="7A4E24">
-                  <a:alpha val="34000"/>
-                </a:srgbClr>
-              </a:gs>
-              <a:gs pos="46000">
-                <a:srgbClr val="7A4E24">
-                  <a:alpha val="14000"/>
-                </a:srgbClr>
-              </a:gs>
-              <a:gs pos="100000">
-                <a:srgbClr val="232E26">
-                  <a:alpha val="0"/>
-                </a:srgbClr>
-              </a:gs>
-            </a:gsLst>
-            <a:path path="shape"/>
-          </a:gradFill>
-          <a:ln xmlns:a="http://schemas.openxmlformats.org/drawingml/2006/main" w="0">
-            <a:noFill/>
-            <a:prstDash val="solid"/>
-          </a:ln>
-        </p:spPr>
-      </p:sp>
-      <p:sp>
-        <p:nvSpPr>
           <p:cNvPr id="2" name="mat-cover-kicker">
             <a:extLst xmlns:a="http://schemas.openxmlformats.org/drawingml/2006/main">
               <a:ext uri="{FF2B5EF4-FFF2-40B4-BE49-F238E27FC236}">
@@ -2666,6 +2563,7 @@
           <a:lstStyle xmlns:a="http://schemas.openxmlformats.org/drawingml/2006/main"/>
           <a:p xmlns:a="http://schemas.openxmlformats.org/drawingml/2006/main">
             <a:pPr algn="l">
+              <a:buNone/>
               <a:defRPr sz="1050" b="0" i="0">
                 <a:solidFill>
                   <a:srgbClr val="C07030"/>
@@ -2826,7 +2724,7 @@
         <p:spPr>
           <a:xfrm xmlns:a="http://schemas.openxmlformats.org/drawingml/2006/main">
             <a:off x="800100" y="4819650"/>
-            <a:ext cx="7239000" cy="685800"/>
+            <a:ext cx="8382000" cy="990600"/>
           </a:xfrm>
           <a:prstGeom xmlns:a="http://schemas.openxmlformats.org/drawingml/2006/main" prst="rect">
             <a:avLst/>
@@ -2839,7 +2737,7 @@
         </p:spPr>
         <p:txBody>
           <a:bodyPr xmlns:a="http://schemas.openxmlformats.org/drawingml/2006/main" wrap="square" lIns="0" tIns="0" rIns="0" bIns="0" anchor="t">
-            <a:normAutofit fontScale="93985"/>
+            <a:normAutofit fontScale="100000"/>
           </a:bodyPr>
           <a:lstStyle xmlns:a="http://schemas.openxmlformats.org/drawingml/2006/main"/>
           <a:p xmlns:a="http://schemas.openxmlformats.org/drawingml/2006/main">
@@ -2866,7 +2764,7 @@
                 <a:ea typeface="DM Sans Text"/>
                 <a:cs typeface="DM Sans Text"/>
               </a:rPr>
-              <a:t>A small field guide to rooms that disappear when the music starts.</a:t>
+              <a:t>A small field guide to listening rooms that disappear when the music starts, leaving nothing between the listener and the record.</a:t>
             </a:r>
           </a:p>
         </p:txBody>
@@ -2906,6 +2804,7 @@
           <a:lstStyle xmlns:a="http://schemas.openxmlformats.org/drawingml/2006/main"/>
           <a:p xmlns:a="http://schemas.openxmlformats.org/drawingml/2006/main">
             <a:pPr algn="l">
+              <a:buNone/>
               <a:defRPr sz="900" b="0" i="0">
                 <a:solidFill>
                   <a:srgbClr val="F0E8D2">
@@ -2929,64 +2828,6 @@
                 <a:cs typeface="DM Mono Labels"/>
               </a:rPr>
               <a:t>LISTENING NOTE 01 / 2026</a:t>
-            </a:r>
-          </a:p>
-        </p:txBody>
-      </p:sp>
-      <p:sp>
-        <p:nvSpPr>
-          <p:cNvPr id="7" name="mat-cover-mark">
-            <a:extLst xmlns:a="http://schemas.openxmlformats.org/drawingml/2006/main">
-              <a:ext uri="{FF2B5EF4-FFF2-40B4-BE49-F238E27FC236}">
-                <a16:creationId xmlns:a16="http://schemas.microsoft.com/office/drawing/2014/main" id="{F01D7E5F-22FD-410F-9C72-1A614E8D3770}"/>
-              </a:ext>
-            </a:extLst>
-          </p:cNvPr>
-          <p:cNvSpPr>
-            <a:spLocks xmlns:a="http://schemas.openxmlformats.org/drawingml/2006/main" noGrp="1"/>
-          </p:cNvSpPr>
-          <p:nvPr/>
-        </p:nvSpPr>
-        <p:spPr>
-          <a:xfrm xmlns:a="http://schemas.openxmlformats.org/drawingml/2006/main">
-            <a:off x="9677400" y="4914900"/>
-            <a:ext cx="1638300" cy="838200"/>
-          </a:xfrm>
-          <a:prstGeom xmlns:a="http://schemas.openxmlformats.org/drawingml/2006/main" prst="rect">
-            <a:avLst/>
-          </a:prstGeom>
-          <a:noFill xmlns:a="http://schemas.openxmlformats.org/drawingml/2006/main"/>
-          <a:ln xmlns:a="http://schemas.openxmlformats.org/drawingml/2006/main" w="0">
-            <a:noFill/>
-            <a:prstDash val="solid"/>
-          </a:ln>
-        </p:spPr>
-        <p:txBody>
-          <a:bodyPr xmlns:a="http://schemas.openxmlformats.org/drawingml/2006/main" wrap="square" lIns="0" tIns="0" rIns="0" bIns="0" anchor="ctr">
-            <a:normAutofit fontScale="100000"/>
-          </a:bodyPr>
-          <a:lstStyle xmlns:a="http://schemas.openxmlformats.org/drawingml/2006/main"/>
-          <a:p xmlns:a="http://schemas.openxmlformats.org/drawingml/2006/main">
-            <a:pPr algn="r">
-              <a:defRPr sz="4500" b="1" i="0">
-                <a:solidFill>
-                  <a:srgbClr val="C07030"/>
-                </a:solidFill>
-                <a:latin typeface="Bricolage Grotesque Heading"/>
-                <a:ea typeface="Bricolage Grotesque Heading"/>
-                <a:cs typeface="Bricolage Grotesque Heading"/>
-              </a:defRPr>
-            </a:pPr>
-            <a:r>
-              <a:rPr sz="4500" b="1" i="0">
-                <a:solidFill>
-                  <a:srgbClr val="C07030"/>
-                </a:solidFill>
-                <a:latin typeface="Bricolage Grotesque Heading"/>
-                <a:ea typeface="Bricolage Grotesque Heading"/>
-                <a:cs typeface="Bricolage Grotesque Heading"/>
-              </a:rPr>
-              <a:t>33⅓</a:t>
             </a:r>
           </a:p>
         </p:txBody>
@@ -3022,7 +2863,7 @@
       </p:grpSpPr>
       <p:sp>
         <p:nvSpPr>
-          <p:cNvPr id="1" name="mat-top-rule-2">
+          <p:cNvPr id="21" name="mat-top-rule-2">
             <a:extLst xmlns:a="http://schemas.openxmlformats.org/drawingml/2006/main">
               <a:ext uri="{FF2B5EF4-FFF2-40B4-BE49-F238E27FC236}">
                 <a16:creationId xmlns:a16="http://schemas.microsoft.com/office/drawing/2014/main" id="{6DB7ECB2-37B8-418D-BD73-DE9DE2E3B345}"/>
@@ -3088,6 +2929,7 @@
           <a:lstStyle xmlns:a="http://schemas.openxmlformats.org/drawingml/2006/main"/>
           <a:p xmlns:a="http://schemas.openxmlformats.org/drawingml/2006/main">
             <a:pPr algn="l">
+              <a:buNone/>
               <a:defRPr sz="975" b="0" i="0">
                 <a:solidFill>
                   <a:srgbClr val="232E26"/>
@@ -3146,6 +2988,7 @@
           <a:lstStyle xmlns:a="http://schemas.openxmlformats.org/drawingml/2006/main"/>
           <a:p xmlns:a="http://schemas.openxmlformats.org/drawingml/2006/main">
             <a:pPr algn="r">
+              <a:buNone/>
               <a:defRPr sz="975" b="0" i="0">
                 <a:solidFill>
                   <a:srgbClr val="232E26"/>
@@ -3237,6 +3080,7 @@
           <a:lstStyle xmlns:a="http://schemas.openxmlformats.org/drawingml/2006/main"/>
           <a:p xmlns:a="http://schemas.openxmlformats.org/drawingml/2006/main">
             <a:pPr algn="l">
+              <a:buNone/>
               <a:defRPr sz="750" b="0" i="0">
                 <a:solidFill>
                   <a:srgbClr val="232E26">
@@ -3299,6 +3143,7 @@
           <a:lstStyle xmlns:a="http://schemas.openxmlformats.org/drawingml/2006/main"/>
           <a:p xmlns:a="http://schemas.openxmlformats.org/drawingml/2006/main">
             <a:pPr algn="l">
+              <a:buNone/>
               <a:defRPr sz="1050" b="0" i="0">
                 <a:solidFill>
                   <a:srgbClr val="C07030"/>
@@ -3419,6 +3264,7 @@
           <a:lstStyle xmlns:a="http://schemas.openxmlformats.org/drawingml/2006/main"/>
           <a:p xmlns:a="http://schemas.openxmlformats.org/drawingml/2006/main">
             <a:pPr algn="l">
+              <a:buNone/>
               <a:defRPr sz="3150" b="1" i="0">
                 <a:solidFill>
                   <a:srgbClr val="C07030"/>
@@ -3510,6 +3356,7 @@
           <a:lstStyle xmlns:a="http://schemas.openxmlformats.org/drawingml/2006/main"/>
           <a:p xmlns:a="http://schemas.openxmlformats.org/drawingml/2006/main">
             <a:pPr algn="l">
+              <a:buNone/>
               <a:defRPr sz="1050" b="0" i="0">
                 <a:solidFill>
                   <a:srgbClr val="C07030"/>
@@ -3568,6 +3415,7 @@
           <a:lstStyle xmlns:a="http://schemas.openxmlformats.org/drawingml/2006/main"/>
           <a:p xmlns:a="http://schemas.openxmlformats.org/drawingml/2006/main">
             <a:pPr algn="l">
+              <a:buNone/>
               <a:defRPr sz="1950" b="1" i="0">
                 <a:solidFill>
                   <a:srgbClr val="232E26"/>
@@ -3626,6 +3474,7 @@
           <a:lstStyle xmlns:a="http://schemas.openxmlformats.org/drawingml/2006/main"/>
           <a:p xmlns:a="http://schemas.openxmlformats.org/drawingml/2006/main">
             <a:pPr algn="l">
+              <a:buNone/>
               <a:defRPr sz="1425" b="0" i="0">
                 <a:solidFill>
                   <a:srgbClr val="1E2820"/>
@@ -3717,6 +3566,7 @@
           <a:lstStyle xmlns:a="http://schemas.openxmlformats.org/drawingml/2006/main"/>
           <a:p xmlns:a="http://schemas.openxmlformats.org/drawingml/2006/main">
             <a:pPr algn="l">
+              <a:buNone/>
               <a:defRPr sz="1050" b="0" i="0">
                 <a:solidFill>
                   <a:srgbClr val="C07030"/>
@@ -3775,6 +3625,7 @@
           <a:lstStyle xmlns:a="http://schemas.openxmlformats.org/drawingml/2006/main"/>
           <a:p xmlns:a="http://schemas.openxmlformats.org/drawingml/2006/main">
             <a:pPr algn="l">
+              <a:buNone/>
               <a:defRPr sz="1950" b="1" i="0">
                 <a:solidFill>
                   <a:srgbClr val="232E26"/>
@@ -3833,6 +3684,7 @@
           <a:lstStyle xmlns:a="http://schemas.openxmlformats.org/drawingml/2006/main"/>
           <a:p xmlns:a="http://schemas.openxmlformats.org/drawingml/2006/main">
             <a:pPr algn="l">
+              <a:buNone/>
               <a:defRPr sz="1425" b="0" i="0">
                 <a:solidFill>
                   <a:srgbClr val="1E2820"/>
@@ -3924,6 +3776,7 @@
           <a:lstStyle xmlns:a="http://schemas.openxmlformats.org/drawingml/2006/main"/>
           <a:p xmlns:a="http://schemas.openxmlformats.org/drawingml/2006/main">
             <a:pPr algn="l">
+              <a:buNone/>
               <a:defRPr sz="1050" b="0" i="0">
                 <a:solidFill>
                   <a:srgbClr val="C07030"/>
@@ -3982,6 +3835,7 @@
           <a:lstStyle xmlns:a="http://schemas.openxmlformats.org/drawingml/2006/main"/>
           <a:p xmlns:a="http://schemas.openxmlformats.org/drawingml/2006/main">
             <a:pPr algn="l">
+              <a:buNone/>
               <a:defRPr sz="1950" b="1" i="0">
                 <a:solidFill>
                   <a:srgbClr val="232E26"/>
@@ -4040,6 +3894,7 @@
           <a:lstStyle xmlns:a="http://schemas.openxmlformats.org/drawingml/2006/main"/>
           <a:p xmlns:a="http://schemas.openxmlformats.org/drawingml/2006/main">
             <a:pPr algn="l">
+              <a:buNone/>
               <a:defRPr sz="1425" b="0" i="0">
                 <a:solidFill>
                   <a:srgbClr val="1E2820"/>
@@ -4078,9 +3933,23 @@
   <p:cSld>
     <p:bg>
       <p:bgPr>
-        <a:solidFill xmlns:a="http://schemas.openxmlformats.org/drawingml/2006/main">
-          <a:srgbClr val="232E26"/>
-        </a:solidFill>
+        <a:gradFill xmlns:a="http://schemas.openxmlformats.org/drawingml/2006/main">
+          <a:gsLst>
+            <a:gs pos="0">
+              <a:srgbClr val="232E26"/>
+            </a:gs>
+            <a:gs pos="56000">
+              <a:srgbClr val="232E26"/>
+            </a:gs>
+            <a:gs pos="78000">
+              <a:srgbClr val="2B3026"/>
+            </a:gs>
+            <a:gs pos="100000">
+              <a:srgbClr val="514029"/>
+            </a:gs>
+          </a:gsLst>
+          <a:lin ang="2700000"/>
+        </a:gradFill>
       </p:bgPr>
     </p:bg>
     <p:spTree>
@@ -4094,54 +3963,6 @@
       </p:grpSpPr>
       <p:sp>
         <p:nvSpPr>
-          <p:cNvPr id="1" name="mat-layers-wood-glow">
-            <a:extLst xmlns:a="http://schemas.openxmlformats.org/drawingml/2006/main">
-              <a:ext uri="{FF2B5EF4-FFF2-40B4-BE49-F238E27FC236}">
-                <a16:creationId xmlns:a16="http://schemas.microsoft.com/office/drawing/2014/main" id="{5968D4F0-B8D0-46A0-A32A-DB6AAF59B369}"/>
-              </a:ext>
-            </a:extLst>
-          </p:cNvPr>
-          <p:cNvSpPr>
-            <a:spLocks xmlns:a="http://schemas.openxmlformats.org/drawingml/2006/main" noGrp="1"/>
-          </p:cNvSpPr>
-          <p:nvPr/>
-        </p:nvSpPr>
-        <p:spPr>
-          <a:xfrm xmlns:a="http://schemas.openxmlformats.org/drawingml/2006/main">
-            <a:off x="7810500" y="3371850"/>
-            <a:ext cx="4324350" cy="3276600"/>
-          </a:xfrm>
-          <a:prstGeom xmlns:a="http://schemas.openxmlformats.org/drawingml/2006/main" prst="ellipse">
-            <a:avLst/>
-          </a:prstGeom>
-          <a:gradFill xmlns:a="http://schemas.openxmlformats.org/drawingml/2006/main">
-            <a:gsLst>
-              <a:gs pos="0">
-                <a:srgbClr val="7A4E24">
-                  <a:alpha val="34000"/>
-                </a:srgbClr>
-              </a:gs>
-              <a:gs pos="46000">
-                <a:srgbClr val="7A4E24">
-                  <a:alpha val="14000"/>
-                </a:srgbClr>
-              </a:gs>
-              <a:gs pos="100000">
-                <a:srgbClr val="232E26">
-                  <a:alpha val="0"/>
-                </a:srgbClr>
-              </a:gs>
-            </a:gsLst>
-            <a:path path="shape"/>
-          </a:gradFill>
-          <a:ln xmlns:a="http://schemas.openxmlformats.org/drawingml/2006/main" w="0">
-            <a:noFill/>
-            <a:prstDash val="solid"/>
-          </a:ln>
-        </p:spPr>
-      </p:sp>
-      <p:sp>
-        <p:nvSpPr>
           <p:cNvPr id="2" name="mat-top-rule-3">
             <a:extLst xmlns:a="http://schemas.openxmlformats.org/drawingml/2006/main">
               <a:ext uri="{FF2B5EF4-FFF2-40B4-BE49-F238E27FC236}">
@@ -4208,6 +4029,7 @@
           <a:lstStyle xmlns:a="http://schemas.openxmlformats.org/drawingml/2006/main"/>
           <a:p xmlns:a="http://schemas.openxmlformats.org/drawingml/2006/main">
             <a:pPr algn="l">
+              <a:buNone/>
               <a:defRPr sz="975" b="0" i="0">
                 <a:solidFill>
                   <a:srgbClr val="F0E8D2"/>
@@ -4266,6 +4088,7 @@
           <a:lstStyle xmlns:a="http://schemas.openxmlformats.org/drawingml/2006/main"/>
           <a:p xmlns:a="http://schemas.openxmlformats.org/drawingml/2006/main">
             <a:pPr algn="r">
+              <a:buNone/>
               <a:defRPr sz="975" b="0" i="0">
                 <a:solidFill>
                   <a:srgbClr val="F0E8D2"/>
@@ -4357,6 +4180,7 @@
           <a:lstStyle xmlns:a="http://schemas.openxmlformats.org/drawingml/2006/main"/>
           <a:p xmlns:a="http://schemas.openxmlformats.org/drawingml/2006/main">
             <a:pPr algn="l">
+              <a:buNone/>
               <a:defRPr sz="750" b="0" i="0">
                 <a:solidFill>
                   <a:srgbClr val="F0E8D2">
@@ -4605,6 +4429,7 @@
           <a:lstStyle xmlns:a="http://schemas.openxmlformats.org/drawingml/2006/main"/>
           <a:p xmlns:a="http://schemas.openxmlformats.org/drawingml/2006/main">
             <a:pPr algn="l">
+              <a:buNone/>
               <a:defRPr sz="975" b="0" i="0">
                 <a:solidFill>
                   <a:srgbClr val="C07030"/>
@@ -4696,6 +4521,7 @@
           <a:lstStyle xmlns:a="http://schemas.openxmlformats.org/drawingml/2006/main"/>
           <a:p xmlns:a="http://schemas.openxmlformats.org/drawingml/2006/main">
             <a:pPr algn="l">
+              <a:buNone/>
               <a:defRPr sz="975" b="0" i="0">
                 <a:solidFill>
                   <a:srgbClr val="C07030"/>
@@ -4754,6 +4580,7 @@
           <a:lstStyle xmlns:a="http://schemas.openxmlformats.org/drawingml/2006/main"/>
           <a:p xmlns:a="http://schemas.openxmlformats.org/drawingml/2006/main">
             <a:pPr algn="l">
+              <a:buNone/>
               <a:defRPr sz="1800" b="1" i="0">
                 <a:solidFill>
                   <a:srgbClr val="232E26"/>
@@ -4907,6 +4734,7 @@
           <a:lstStyle xmlns:a="http://schemas.openxmlformats.org/drawingml/2006/main"/>
           <a:p xmlns:a="http://schemas.openxmlformats.org/drawingml/2006/main">
             <a:pPr algn="l">
+              <a:buNone/>
               <a:defRPr sz="975" b="0" i="0">
                 <a:solidFill>
                   <a:srgbClr val="C07030"/>
@@ -4965,6 +4793,7 @@
           <a:lstStyle xmlns:a="http://schemas.openxmlformats.org/drawingml/2006/main"/>
           <a:p xmlns:a="http://schemas.openxmlformats.org/drawingml/2006/main">
             <a:pPr algn="l">
+              <a:buNone/>
               <a:defRPr sz="1800" b="1" i="0">
                 <a:solidFill>
                   <a:srgbClr val="232E26"/>
@@ -5118,6 +4947,7 @@
           <a:lstStyle xmlns:a="http://schemas.openxmlformats.org/drawingml/2006/main"/>
           <a:p xmlns:a="http://schemas.openxmlformats.org/drawingml/2006/main">
             <a:pPr algn="l">
+              <a:buNone/>
               <a:defRPr sz="975" b="0" i="0">
                 <a:solidFill>
                   <a:srgbClr val="C07030"/>
@@ -5176,6 +5006,7 @@
           <a:lstStyle xmlns:a="http://schemas.openxmlformats.org/drawingml/2006/main"/>
           <a:p xmlns:a="http://schemas.openxmlformats.org/drawingml/2006/main">
             <a:pPr algn="l">
+              <a:buNone/>
               <a:defRPr sz="1800" b="1" i="0">
                 <a:solidFill>
                   <a:srgbClr val="232E26"/>
@@ -5329,6 +5160,7 @@
           <a:lstStyle xmlns:a="http://schemas.openxmlformats.org/drawingml/2006/main"/>
           <a:p xmlns:a="http://schemas.openxmlformats.org/drawingml/2006/main">
             <a:pPr algn="l">
+              <a:buNone/>
               <a:defRPr sz="975" b="0" i="0">
                 <a:solidFill>
                   <a:srgbClr val="C07030"/>
@@ -5387,6 +5219,7 @@
           <a:lstStyle xmlns:a="http://schemas.openxmlformats.org/drawingml/2006/main"/>
           <a:p xmlns:a="http://schemas.openxmlformats.org/drawingml/2006/main">
             <a:pPr algn="l">
+              <a:buNone/>
               <a:defRPr sz="1800" b="1" i="0">
                 <a:solidFill>
                   <a:srgbClr val="232E26"/>
@@ -5503,7 +5336,7 @@
       </p:grpSpPr>
       <p:sp>
         <p:nvSpPr>
-          <p:cNvPr id="1" name="mat-top-rule-4">
+          <p:cNvPr id="21" name="mat-top-rule-4">
             <a:extLst xmlns:a="http://schemas.openxmlformats.org/drawingml/2006/main">
               <a:ext uri="{FF2B5EF4-FFF2-40B4-BE49-F238E27FC236}">
                 <a16:creationId xmlns:a16="http://schemas.microsoft.com/office/drawing/2014/main" id="{813FCE9B-E297-4B6B-A3B8-1A5EAE48480E}"/>
@@ -5569,6 +5402,7 @@
           <a:lstStyle xmlns:a="http://schemas.openxmlformats.org/drawingml/2006/main"/>
           <a:p xmlns:a="http://schemas.openxmlformats.org/drawingml/2006/main">
             <a:pPr algn="l">
+              <a:buNone/>
               <a:defRPr sz="975" b="0" i="0">
                 <a:solidFill>
                   <a:srgbClr val="232E26"/>
@@ -5627,6 +5461,7 @@
           <a:lstStyle xmlns:a="http://schemas.openxmlformats.org/drawingml/2006/main"/>
           <a:p xmlns:a="http://schemas.openxmlformats.org/drawingml/2006/main">
             <a:pPr algn="r">
+              <a:buNone/>
               <a:defRPr sz="975" b="0" i="0">
                 <a:solidFill>
                   <a:srgbClr val="232E26"/>
@@ -5718,6 +5553,7 @@
           <a:lstStyle xmlns:a="http://schemas.openxmlformats.org/drawingml/2006/main"/>
           <a:p xmlns:a="http://schemas.openxmlformats.org/drawingml/2006/main">
             <a:pPr algn="l">
+              <a:buNone/>
               <a:defRPr sz="750" b="0" i="0">
                 <a:solidFill>
                   <a:srgbClr val="232E26">
@@ -5780,6 +5616,7 @@
           <a:lstStyle xmlns:a="http://schemas.openxmlformats.org/drawingml/2006/main"/>
           <a:p xmlns:a="http://schemas.openxmlformats.org/drawingml/2006/main">
             <a:pPr algn="l">
+              <a:buNone/>
               <a:defRPr sz="3900" b="1" i="0">
                 <a:solidFill>
                   <a:srgbClr val="232E26"/>
@@ -5999,6 +5836,7 @@
           <a:lstStyle xmlns:a="http://schemas.openxmlformats.org/drawingml/2006/main"/>
           <a:p xmlns:a="http://schemas.openxmlformats.org/drawingml/2006/main">
             <a:pPr algn="l">
+              <a:buNone/>
               <a:defRPr sz="5400" b="1" i="0">
                 <a:solidFill>
                   <a:srgbClr val="232E26"/>
@@ -6057,6 +5895,7 @@
           <a:lstStyle xmlns:a="http://schemas.openxmlformats.org/drawingml/2006/main"/>
           <a:p xmlns:a="http://schemas.openxmlformats.org/drawingml/2006/main">
             <a:pPr algn="l">
+              <a:buNone/>
               <a:defRPr sz="1050" b="0" i="0">
                 <a:solidFill>
                   <a:srgbClr val="C07030"/>
@@ -6177,6 +6016,7 @@
           <a:lstStyle xmlns:a="http://schemas.openxmlformats.org/drawingml/2006/main"/>
           <a:p xmlns:a="http://schemas.openxmlformats.org/drawingml/2006/main">
             <a:pPr algn="l">
+              <a:buNone/>
               <a:defRPr sz="5400" b="1" i="0">
                 <a:solidFill>
                   <a:srgbClr val="232E26"/>
@@ -6235,6 +6075,7 @@
           <a:lstStyle xmlns:a="http://schemas.openxmlformats.org/drawingml/2006/main"/>
           <a:p xmlns:a="http://schemas.openxmlformats.org/drawingml/2006/main">
             <a:pPr algn="l">
+              <a:buNone/>
               <a:defRPr sz="1050" b="0" i="0">
                 <a:solidFill>
                   <a:srgbClr val="C07030"/>
@@ -6355,6 +6196,7 @@
           <a:lstStyle xmlns:a="http://schemas.openxmlformats.org/drawingml/2006/main"/>
           <a:p xmlns:a="http://schemas.openxmlformats.org/drawingml/2006/main">
             <a:pPr algn="l">
+              <a:buNone/>
               <a:defRPr sz="5400" b="1" i="0">
                 <a:solidFill>
                   <a:srgbClr val="232E26"/>
@@ -6413,6 +6255,7 @@
           <a:lstStyle xmlns:a="http://schemas.openxmlformats.org/drawingml/2006/main"/>
           <a:p xmlns:a="http://schemas.openxmlformats.org/drawingml/2006/main">
             <a:pPr algn="l">
+              <a:buNone/>
               <a:defRPr sz="1050" b="0" i="0">
                 <a:solidFill>
                   <a:srgbClr val="C07030"/>
@@ -6533,6 +6376,7 @@
           <a:lstStyle xmlns:a="http://schemas.openxmlformats.org/drawingml/2006/main"/>
           <a:p xmlns:a="http://schemas.openxmlformats.org/drawingml/2006/main">
             <a:pPr algn="l">
+              <a:buNone/>
               <a:defRPr sz="825" b="0" i="0">
                 <a:solidFill>
                   <a:srgbClr val="C07030"/>
@@ -6571,9 +6415,23 @@
   <p:cSld>
     <p:bg>
       <p:bgPr>
-        <a:solidFill xmlns:a="http://schemas.openxmlformats.org/drawingml/2006/main">
-          <a:srgbClr val="232E26"/>
-        </a:solidFill>
+        <a:gradFill xmlns:a="http://schemas.openxmlformats.org/drawingml/2006/main">
+          <a:gsLst>
+            <a:gs pos="0">
+              <a:srgbClr val="232E26"/>
+            </a:gs>
+            <a:gs pos="56000">
+              <a:srgbClr val="232E26"/>
+            </a:gs>
+            <a:gs pos="78000">
+              <a:srgbClr val="2B3026"/>
+            </a:gs>
+            <a:gs pos="100000">
+              <a:srgbClr val="514029"/>
+            </a:gs>
+          </a:gsLst>
+          <a:lin ang="2700000"/>
+        </a:gradFill>
       </p:bgPr>
     </p:bg>
     <p:spTree>
@@ -6587,54 +6445,6 @@
       </p:grpSpPr>
       <p:sp>
         <p:nvSpPr>
-          <p:cNvPr id="1" name="mat-decay-wood-glow">
-            <a:extLst xmlns:a="http://schemas.openxmlformats.org/drawingml/2006/main">
-              <a:ext uri="{FF2B5EF4-FFF2-40B4-BE49-F238E27FC236}">
-                <a16:creationId xmlns:a16="http://schemas.microsoft.com/office/drawing/2014/main" id="{52E4AB02-7595-42F2-BDC0-95400FCCE2B9}"/>
-              </a:ext>
-            </a:extLst>
-          </p:cNvPr>
-          <p:cNvSpPr>
-            <a:spLocks xmlns:a="http://schemas.openxmlformats.org/drawingml/2006/main" noGrp="1"/>
-          </p:cNvSpPr>
-          <p:nvPr/>
-        </p:nvSpPr>
-        <p:spPr>
-          <a:xfrm xmlns:a="http://schemas.openxmlformats.org/drawingml/2006/main">
-            <a:off x="7810500" y="3371850"/>
-            <a:ext cx="4324350" cy="3276600"/>
-          </a:xfrm>
-          <a:prstGeom xmlns:a="http://schemas.openxmlformats.org/drawingml/2006/main" prst="ellipse">
-            <a:avLst/>
-          </a:prstGeom>
-          <a:gradFill xmlns:a="http://schemas.openxmlformats.org/drawingml/2006/main">
-            <a:gsLst>
-              <a:gs pos="0">
-                <a:srgbClr val="7A4E24">
-                  <a:alpha val="34000"/>
-                </a:srgbClr>
-              </a:gs>
-              <a:gs pos="46000">
-                <a:srgbClr val="7A4E24">
-                  <a:alpha val="14000"/>
-                </a:srgbClr>
-              </a:gs>
-              <a:gs pos="100000">
-                <a:srgbClr val="232E26">
-                  <a:alpha val="0"/>
-                </a:srgbClr>
-              </a:gs>
-            </a:gsLst>
-            <a:path path="shape"/>
-          </a:gradFill>
-          <a:ln xmlns:a="http://schemas.openxmlformats.org/drawingml/2006/main" w="0">
-            <a:noFill/>
-            <a:prstDash val="solid"/>
-          </a:ln>
-        </p:spPr>
-      </p:sp>
-      <p:sp>
-        <p:nvSpPr>
           <p:cNvPr id="2" name="mat-top-rule-5">
             <a:extLst xmlns:a="http://schemas.openxmlformats.org/drawingml/2006/main">
               <a:ext uri="{FF2B5EF4-FFF2-40B4-BE49-F238E27FC236}">
@@ -6701,6 +6511,7 @@
           <a:lstStyle xmlns:a="http://schemas.openxmlformats.org/drawingml/2006/main"/>
           <a:p xmlns:a="http://schemas.openxmlformats.org/drawingml/2006/main">
             <a:pPr algn="l">
+              <a:buNone/>
               <a:defRPr sz="975" b="0" i="0">
                 <a:solidFill>
                   <a:srgbClr val="F0E8D2"/>
@@ -6759,6 +6570,7 @@
           <a:lstStyle xmlns:a="http://schemas.openxmlformats.org/drawingml/2006/main"/>
           <a:p xmlns:a="http://schemas.openxmlformats.org/drawingml/2006/main">
             <a:pPr algn="r">
+              <a:buNone/>
               <a:defRPr sz="975" b="0" i="0">
                 <a:solidFill>
                   <a:srgbClr val="F0E8D2"/>
@@ -6850,6 +6662,7 @@
           <a:lstStyle xmlns:a="http://schemas.openxmlformats.org/drawingml/2006/main"/>
           <a:p xmlns:a="http://schemas.openxmlformats.org/drawingml/2006/main">
             <a:pPr algn="l">
+              <a:buNone/>
               <a:defRPr sz="750" b="0" i="0">
                 <a:solidFill>
                   <a:srgbClr val="F0E8D2">
@@ -6912,6 +6725,7 @@
           <a:lstStyle xmlns:a="http://schemas.openxmlformats.org/drawingml/2006/main"/>
           <a:p xmlns:a="http://schemas.openxmlformats.org/drawingml/2006/main">
             <a:pPr algn="l">
+              <a:buNone/>
               <a:defRPr sz="3675" b="1" i="0">
                 <a:solidFill>
                   <a:srgbClr val="F0E8D2"/>
@@ -6970,6 +6784,7 @@
           <a:lstStyle xmlns:a="http://schemas.openxmlformats.org/drawingml/2006/main"/>
           <a:p xmlns:a="http://schemas.openxmlformats.org/drawingml/2006/main">
             <a:pPr algn="l">
+              <a:buNone/>
               <a:defRPr sz="1425" b="0" i="0">
                 <a:solidFill>
                   <a:srgbClr val="F0E8D2">
@@ -7009,7 +6824,7 @@
         </p:xfrm>
         <a:graphic xmlns:a="http://schemas.openxmlformats.org/drawingml/2006/main">
           <a:graphicData uri="http://schemas.openxmlformats.org/drawingml/2006/chart">
-            <c:chart xmlns:r="http://schemas.openxmlformats.org/officeDocument/2006/relationships" xmlns:c="http://schemas.openxmlformats.org/drawingml/2006/chart" r:id="Rdde3b38529d546a6"/>
+            <c:chart xmlns:r="http://schemas.openxmlformats.org/officeDocument/2006/relationships" xmlns:c="http://schemas.openxmlformats.org/drawingml/2006/chart" r:id="Refd3c8156a0f47df"/>
           </a:graphicData>
         </a:graphic>
       </p:graphicFrame>
@@ -7048,6 +6863,7 @@
           <a:lstStyle xmlns:a="http://schemas.openxmlformats.org/drawingml/2006/main"/>
           <a:p xmlns:a="http://schemas.openxmlformats.org/drawingml/2006/main">
             <a:pPr algn="l">
+              <a:buNone/>
               <a:defRPr sz="825" b="0" i="0">
                 <a:solidFill>
                   <a:srgbClr val="C07030"/>
@@ -7102,7 +6918,7 @@
       </p:grpSpPr>
       <p:sp>
         <p:nvSpPr>
-          <p:cNvPr id="1" name="mat-top-rule-6">
+          <p:cNvPr id="11" name="mat-top-rule-6">
             <a:extLst xmlns:a="http://schemas.openxmlformats.org/drawingml/2006/main">
               <a:ext uri="{FF2B5EF4-FFF2-40B4-BE49-F238E27FC236}">
                 <a16:creationId xmlns:a16="http://schemas.microsoft.com/office/drawing/2014/main" id="{B6965FD2-1631-4E32-869A-3095D8155D17}"/>
@@ -7168,6 +6984,7 @@
           <a:lstStyle xmlns:a="http://schemas.openxmlformats.org/drawingml/2006/main"/>
           <a:p xmlns:a="http://schemas.openxmlformats.org/drawingml/2006/main">
             <a:pPr algn="l">
+              <a:buNone/>
               <a:defRPr sz="975" b="0" i="0">
                 <a:solidFill>
                   <a:srgbClr val="232E26"/>
@@ -7226,6 +7043,7 @@
           <a:lstStyle xmlns:a="http://schemas.openxmlformats.org/drawingml/2006/main"/>
           <a:p xmlns:a="http://schemas.openxmlformats.org/drawingml/2006/main">
             <a:pPr algn="r">
+              <a:buNone/>
               <a:defRPr sz="975" b="0" i="0">
                 <a:solidFill>
                   <a:srgbClr val="232E26"/>
@@ -7317,6 +7135,7 @@
           <a:lstStyle xmlns:a="http://schemas.openxmlformats.org/drawingml/2006/main"/>
           <a:p xmlns:a="http://schemas.openxmlformats.org/drawingml/2006/main">
             <a:pPr algn="l">
+              <a:buNone/>
               <a:defRPr sz="750" b="0" i="0">
                 <a:solidFill>
                   <a:srgbClr val="232E26">
@@ -7379,6 +7198,7 @@
           <a:lstStyle xmlns:a="http://schemas.openxmlformats.org/drawingml/2006/main"/>
           <a:p xmlns:a="http://schemas.openxmlformats.org/drawingml/2006/main">
             <a:pPr algn="l">
+              <a:buNone/>
               <a:defRPr sz="3600" b="1" i="0">
                 <a:solidFill>
                   <a:srgbClr val="232E26"/>
@@ -7437,6 +7257,7 @@
           <a:lstStyle xmlns:a="http://schemas.openxmlformats.org/drawingml/2006/main"/>
           <a:p xmlns:a="http://schemas.openxmlformats.org/drawingml/2006/main">
             <a:pPr algn="l">
+              <a:buNone/>
               <a:defRPr sz="1425" b="0" i="0">
                 <a:solidFill>
                   <a:srgbClr val="1E2820"/>
@@ -7462,7 +7283,7 @@
       </p:sp>
       <p:graphicFrame>
         <p:nvGraphicFramePr>
-          <p:cNvPr id="17" name="mat-editable-session-column-chart"/>
+          <p:cNvPr id="20" name="mat-editable-session-column-chart"/>
           <p:cNvGraphicFramePr/>
           <p:nvPr/>
         </p:nvGraphicFramePr>
@@ -7472,7 +7293,7 @@
         </p:xfrm>
         <a:graphic xmlns:a="http://schemas.openxmlformats.org/drawingml/2006/main">
           <a:graphicData uri="http://schemas.openxmlformats.org/drawingml/2006/chart">
-            <c:chart xmlns:r="http://schemas.openxmlformats.org/officeDocument/2006/relationships" xmlns:c="http://schemas.openxmlformats.org/drawingml/2006/chart" r:id="Rbe31ff63ac3f4724"/>
+            <c:chart xmlns:r="http://schemas.openxmlformats.org/officeDocument/2006/relationships" xmlns:c="http://schemas.openxmlformats.org/drawingml/2006/chart" r:id="R207089d9fc4744c7"/>
           </a:graphicData>
         </a:graphic>
       </p:graphicFrame>
@@ -7511,6 +7332,7 @@
           <a:lstStyle xmlns:a="http://schemas.openxmlformats.org/drawingml/2006/main"/>
           <a:p xmlns:a="http://schemas.openxmlformats.org/drawingml/2006/main">
             <a:pPr algn="l">
+              <a:buNone/>
               <a:defRPr sz="825" b="0" i="0">
                 <a:solidFill>
                   <a:srgbClr val="C07030"/>
@@ -7549,9 +7371,23 @@
   <p:cSld>
     <p:bg>
       <p:bgPr>
-        <a:solidFill xmlns:a="http://schemas.openxmlformats.org/drawingml/2006/main">
-          <a:srgbClr val="232E26"/>
-        </a:solidFill>
+        <a:gradFill xmlns:a="http://schemas.openxmlformats.org/drawingml/2006/main">
+          <a:gsLst>
+            <a:gs pos="0">
+              <a:srgbClr val="232E26"/>
+            </a:gs>
+            <a:gs pos="56000">
+              <a:srgbClr val="232E26"/>
+            </a:gs>
+            <a:gs pos="78000">
+              <a:srgbClr val="2B3026"/>
+            </a:gs>
+            <a:gs pos="100000">
+              <a:srgbClr val="514029"/>
+            </a:gs>
+          </a:gsLst>
+          <a:lin ang="2700000"/>
+        </a:gradFill>
       </p:bgPr>
     </p:bg>
     <p:spTree>
@@ -7565,54 +7401,6 @@
       </p:grpSpPr>
       <p:sp>
         <p:nvSpPr>
-          <p:cNvPr id="1" name="mat-ledger-wood-glow">
-            <a:extLst xmlns:a="http://schemas.openxmlformats.org/drawingml/2006/main">
-              <a:ext uri="{FF2B5EF4-FFF2-40B4-BE49-F238E27FC236}">
-                <a16:creationId xmlns:a16="http://schemas.microsoft.com/office/drawing/2014/main" id="{B20F6799-C209-415D-A27C-0BCAA1E807F7}"/>
-              </a:ext>
-            </a:extLst>
-          </p:cNvPr>
-          <p:cNvSpPr>
-            <a:spLocks xmlns:a="http://schemas.openxmlformats.org/drawingml/2006/main" noGrp="1"/>
-          </p:cNvSpPr>
-          <p:nvPr/>
-        </p:nvSpPr>
-        <p:spPr>
-          <a:xfrm xmlns:a="http://schemas.openxmlformats.org/drawingml/2006/main">
-            <a:off x="7810500" y="3371850"/>
-            <a:ext cx="4324350" cy="3276600"/>
-          </a:xfrm>
-          <a:prstGeom xmlns:a="http://schemas.openxmlformats.org/drawingml/2006/main" prst="ellipse">
-            <a:avLst/>
-          </a:prstGeom>
-          <a:gradFill xmlns:a="http://schemas.openxmlformats.org/drawingml/2006/main">
-            <a:gsLst>
-              <a:gs pos="0">
-                <a:srgbClr val="7A4E24">
-                  <a:alpha val="34000"/>
-                </a:srgbClr>
-              </a:gs>
-              <a:gs pos="46000">
-                <a:srgbClr val="7A4E24">
-                  <a:alpha val="14000"/>
-                </a:srgbClr>
-              </a:gs>
-              <a:gs pos="100000">
-                <a:srgbClr val="232E26">
-                  <a:alpha val="0"/>
-                </a:srgbClr>
-              </a:gs>
-            </a:gsLst>
-            <a:path path="shape"/>
-          </a:gradFill>
-          <a:ln xmlns:a="http://schemas.openxmlformats.org/drawingml/2006/main" w="0">
-            <a:noFill/>
-            <a:prstDash val="solid"/>
-          </a:ln>
-        </p:spPr>
-      </p:sp>
-      <p:sp>
-        <p:nvSpPr>
           <p:cNvPr id="2" name="mat-top-rule-7">
             <a:extLst xmlns:a="http://schemas.openxmlformats.org/drawingml/2006/main">
               <a:ext uri="{FF2B5EF4-FFF2-40B4-BE49-F238E27FC236}">
@@ -7679,6 +7467,7 @@
           <a:lstStyle xmlns:a="http://schemas.openxmlformats.org/drawingml/2006/main"/>
           <a:p xmlns:a="http://schemas.openxmlformats.org/drawingml/2006/main">
             <a:pPr algn="l">
+              <a:buNone/>
               <a:defRPr sz="975" b="0" i="0">
                 <a:solidFill>
                   <a:srgbClr val="F0E8D2"/>
@@ -7737,6 +7526,7 @@
           <a:lstStyle xmlns:a="http://schemas.openxmlformats.org/drawingml/2006/main"/>
           <a:p xmlns:a="http://schemas.openxmlformats.org/drawingml/2006/main">
             <a:pPr algn="r">
+              <a:buNone/>
               <a:defRPr sz="975" b="0" i="0">
                 <a:solidFill>
                   <a:srgbClr val="F0E8D2"/>
@@ -7828,6 +7618,7 @@
           <a:lstStyle xmlns:a="http://schemas.openxmlformats.org/drawingml/2006/main"/>
           <a:p xmlns:a="http://schemas.openxmlformats.org/drawingml/2006/main">
             <a:pPr algn="l">
+              <a:buNone/>
               <a:defRPr sz="750" b="0" i="0">
                 <a:solidFill>
                   <a:srgbClr val="F0E8D2">
@@ -7890,6 +7681,7 @@
           <a:lstStyle xmlns:a="http://schemas.openxmlformats.org/drawingml/2006/main"/>
           <a:p xmlns:a="http://schemas.openxmlformats.org/drawingml/2006/main">
             <a:pPr algn="l">
+              <a:buNone/>
               <a:defRPr sz="3675" b="1" i="0">
                 <a:solidFill>
                   <a:srgbClr val="F0E8D2"/>
@@ -7948,6 +7740,7 @@
           <a:lstStyle xmlns:a="http://schemas.openxmlformats.org/drawingml/2006/main"/>
           <a:p xmlns:a="http://schemas.openxmlformats.org/drawingml/2006/main">
             <a:pPr algn="l">
+              <a:buNone/>
               <a:defRPr sz="1425" b="0" i="0">
                 <a:solidFill>
                   <a:srgbClr val="F0E8D2">
@@ -8002,7 +7795,9 @@
                     <a:bodyPr lIns="104775" tIns="57150" rIns="104775" bIns="57150" anchor="ctr"/>
                     <a:lstStyle/>
                     <a:p>
-                      <a:pPr algn="l"/>
+                      <a:pPr algn="l">
+                        <a:buNone/>
+                      </a:pPr>
                       <a:r>
                         <a:rPr sz="1125" b="1">
                           <a:solidFill>
@@ -8027,7 +7822,9 @@
                     <a:bodyPr lIns="104775" tIns="57150" rIns="104775" bIns="57150" anchor="ctr"/>
                     <a:lstStyle/>
                     <a:p>
-                      <a:pPr algn="ctr"/>
+                      <a:pPr algn="ctr">
+                        <a:buNone/>
+                      </a:pPr>
                       <a:r>
                         <a:rPr sz="1125" b="1">
                           <a:solidFill>
@@ -8052,7 +7849,9 @@
                     <a:bodyPr lIns="104775" tIns="57150" rIns="104775" bIns="57150" anchor="ctr"/>
                     <a:lstStyle/>
                     <a:p>
-                      <a:pPr algn="ctr"/>
+                      <a:pPr algn="ctr">
+                        <a:buNone/>
+                      </a:pPr>
                       <a:r>
                         <a:rPr sz="1125" b="1">
                           <a:solidFill>
@@ -8077,7 +7876,9 @@
                     <a:bodyPr lIns="104775" tIns="57150" rIns="104775" bIns="57150" anchor="ctr"/>
                     <a:lstStyle/>
                     <a:p>
-                      <a:pPr algn="ctr"/>
+                      <a:pPr algn="ctr">
+                        <a:buNone/>
+                      </a:pPr>
                       <a:r>
                         <a:rPr sz="1125" b="1">
                           <a:solidFill>
@@ -8102,7 +7903,9 @@
                     <a:bodyPr lIns="104775" tIns="57150" rIns="104775" bIns="57150" anchor="ctr"/>
                     <a:lstStyle/>
                     <a:p>
-                      <a:pPr algn="l"/>
+                      <a:pPr algn="l">
+                        <a:buNone/>
+                      </a:pPr>
                       <a:r>
                         <a:rPr sz="1125" b="1">
                           <a:solidFill>
@@ -8129,7 +7932,9 @@
                     <a:bodyPr lIns="104775" tIns="57150" rIns="104775" bIns="57150" anchor="ctr"/>
                     <a:lstStyle/>
                     <a:p>
-                      <a:pPr algn="l"/>
+                      <a:pPr algn="l">
+                        <a:buNone/>
+                      </a:pPr>
                       <a:r>
                         <a:rPr sz="1425" b="1">
                           <a:solidFill>
@@ -8154,7 +7959,9 @@
                     <a:bodyPr lIns="104775" tIns="57150" rIns="104775" bIns="57150" anchor="ctr"/>
                     <a:lstStyle/>
                     <a:p>
-                      <a:pPr algn="ctr"/>
+                      <a:pPr algn="ctr">
+                        <a:buNone/>
+                      </a:pPr>
                       <a:r>
                         <a:rPr sz="1275" b="0">
                           <a:solidFill>
@@ -8179,7 +7986,9 @@
                     <a:bodyPr lIns="104775" tIns="57150" rIns="104775" bIns="57150" anchor="ctr"/>
                     <a:lstStyle/>
                     <a:p>
-                      <a:pPr algn="ctr"/>
+                      <a:pPr algn="ctr">
+                        <a:buNone/>
+                      </a:pPr>
                       <a:r>
                         <a:rPr sz="1275" b="0">
                           <a:solidFill>
@@ -8204,7 +8013,9 @@
                     <a:bodyPr lIns="104775" tIns="57150" rIns="104775" bIns="57150" anchor="ctr"/>
                     <a:lstStyle/>
                     <a:p>
-                      <a:pPr algn="ctr"/>
+                      <a:pPr algn="ctr">
+                        <a:buNone/>
+                      </a:pPr>
                       <a:r>
                         <a:rPr sz="1275" b="0">
                           <a:solidFill>
@@ -8229,7 +8040,9 @@
                     <a:bodyPr lIns="104775" tIns="57150" rIns="104775" bIns="57150" anchor="ctr"/>
                     <a:lstStyle/>
                     <a:p>
-                      <a:pPr algn="l"/>
+                      <a:pPr algn="l">
+                        <a:buNone/>
+                      </a:pPr>
                       <a:r>
                         <a:rPr sz="1275" b="0">
                           <a:solidFill>
@@ -8256,7 +8069,9 @@
                     <a:bodyPr lIns="104775" tIns="57150" rIns="104775" bIns="57150" anchor="ctr"/>
                     <a:lstStyle/>
                     <a:p>
-                      <a:pPr algn="l"/>
+                      <a:pPr algn="l">
+                        <a:buNone/>
+                      </a:pPr>
                       <a:r>
                         <a:rPr sz="1425" b="1">
                           <a:solidFill>
@@ -8281,7 +8096,9 @@
                     <a:bodyPr lIns="104775" tIns="57150" rIns="104775" bIns="57150" anchor="ctr"/>
                     <a:lstStyle/>
                     <a:p>
-                      <a:pPr algn="ctr"/>
+                      <a:pPr algn="ctr">
+                        <a:buNone/>
+                      </a:pPr>
                       <a:r>
                         <a:rPr sz="1275" b="0">
                           <a:solidFill>
@@ -8306,7 +8123,9 @@
                     <a:bodyPr lIns="104775" tIns="57150" rIns="104775" bIns="57150" anchor="ctr"/>
                     <a:lstStyle/>
                     <a:p>
-                      <a:pPr algn="ctr"/>
+                      <a:pPr algn="ctr">
+                        <a:buNone/>
+                      </a:pPr>
                       <a:r>
                         <a:rPr sz="1275" b="0">
                           <a:solidFill>
@@ -8331,7 +8150,9 @@
                     <a:bodyPr lIns="104775" tIns="57150" rIns="104775" bIns="57150" anchor="ctr"/>
                     <a:lstStyle/>
                     <a:p>
-                      <a:pPr algn="ctr"/>
+                      <a:pPr algn="ctr">
+                        <a:buNone/>
+                      </a:pPr>
                       <a:r>
                         <a:rPr sz="1275" b="0">
                           <a:solidFill>
@@ -8356,7 +8177,9 @@
                     <a:bodyPr lIns="104775" tIns="57150" rIns="104775" bIns="57150" anchor="ctr"/>
                     <a:lstStyle/>
                     <a:p>
-                      <a:pPr algn="l"/>
+                      <a:pPr algn="l">
+                        <a:buNone/>
+                      </a:pPr>
                       <a:r>
                         <a:rPr sz="1275" b="0">
                           <a:solidFill>
@@ -8383,7 +8206,9 @@
                     <a:bodyPr lIns="104775" tIns="57150" rIns="104775" bIns="57150" anchor="ctr"/>
                     <a:lstStyle/>
                     <a:p>
-                      <a:pPr algn="l"/>
+                      <a:pPr algn="l">
+                        <a:buNone/>
+                      </a:pPr>
                       <a:r>
                         <a:rPr sz="1425" b="1">
                           <a:solidFill>
@@ -8408,7 +8233,9 @@
                     <a:bodyPr lIns="104775" tIns="57150" rIns="104775" bIns="57150" anchor="ctr"/>
                     <a:lstStyle/>
                     <a:p>
-                      <a:pPr algn="ctr"/>
+                      <a:pPr algn="ctr">
+                        <a:buNone/>
+                      </a:pPr>
                       <a:r>
                         <a:rPr sz="1275" b="0">
                           <a:solidFill>
@@ -8433,7 +8260,9 @@
                     <a:bodyPr lIns="104775" tIns="57150" rIns="104775" bIns="57150" anchor="ctr"/>
                     <a:lstStyle/>
                     <a:p>
-                      <a:pPr algn="ctr"/>
+                      <a:pPr algn="ctr">
+                        <a:buNone/>
+                      </a:pPr>
                       <a:r>
                         <a:rPr sz="1275" b="0">
                           <a:solidFill>
@@ -8458,7 +8287,9 @@
                     <a:bodyPr lIns="104775" tIns="57150" rIns="104775" bIns="57150" anchor="ctr"/>
                     <a:lstStyle/>
                     <a:p>
-                      <a:pPr algn="ctr"/>
+                      <a:pPr algn="ctr">
+                        <a:buNone/>
+                      </a:pPr>
                       <a:r>
                         <a:rPr sz="1275" b="0">
                           <a:solidFill>
@@ -8483,7 +8314,9 @@
                     <a:bodyPr lIns="104775" tIns="57150" rIns="104775" bIns="57150" anchor="ctr"/>
                     <a:lstStyle/>
                     <a:p>
-                      <a:pPr algn="l"/>
+                      <a:pPr algn="l">
+                        <a:buNone/>
+                      </a:pPr>
                       <a:r>
                         <a:rPr sz="1275" b="0">
                           <a:solidFill>
@@ -8510,7 +8343,9 @@
                     <a:bodyPr lIns="104775" tIns="57150" rIns="104775" bIns="57150" anchor="ctr"/>
                     <a:lstStyle/>
                     <a:p>
-                      <a:pPr algn="l"/>
+                      <a:pPr algn="l">
+                        <a:buNone/>
+                      </a:pPr>
                       <a:r>
                         <a:rPr sz="1425" b="1">
                           <a:solidFill>
@@ -8535,7 +8370,9 @@
                     <a:bodyPr lIns="104775" tIns="57150" rIns="104775" bIns="57150" anchor="ctr"/>
                     <a:lstStyle/>
                     <a:p>
-                      <a:pPr algn="ctr"/>
+                      <a:pPr algn="ctr">
+                        <a:buNone/>
+                      </a:pPr>
                       <a:r>
                         <a:rPr sz="1275" b="0">
                           <a:solidFill>
@@ -8560,7 +8397,9 @@
                     <a:bodyPr lIns="104775" tIns="57150" rIns="104775" bIns="57150" anchor="ctr"/>
                     <a:lstStyle/>
                     <a:p>
-                      <a:pPr algn="ctr"/>
+                      <a:pPr algn="ctr">
+                        <a:buNone/>
+                      </a:pPr>
                       <a:r>
                         <a:rPr sz="1275" b="0">
                           <a:solidFill>
@@ -8585,7 +8424,9 @@
                     <a:bodyPr lIns="104775" tIns="57150" rIns="104775" bIns="57150" anchor="ctr"/>
                     <a:lstStyle/>
                     <a:p>
-                      <a:pPr algn="ctr"/>
+                      <a:pPr algn="ctr">
+                        <a:buNone/>
+                      </a:pPr>
                       <a:r>
                         <a:rPr sz="1275" b="0">
                           <a:solidFill>
@@ -8610,7 +8451,9 @@
                     <a:bodyPr lIns="104775" tIns="57150" rIns="104775" bIns="57150" anchor="ctr"/>
                     <a:lstStyle/>
                     <a:p>
-                      <a:pPr algn="l"/>
+                      <a:pPr algn="l">
+                        <a:buNone/>
+                      </a:pPr>
                       <a:r>
                         <a:rPr sz="1275" b="0">
                           <a:solidFill>
@@ -8637,7 +8480,9 @@
                     <a:bodyPr lIns="104775" tIns="57150" rIns="104775" bIns="57150" anchor="ctr"/>
                     <a:lstStyle/>
                     <a:p>
-                      <a:pPr algn="l"/>
+                      <a:pPr algn="l">
+                        <a:buNone/>
+                      </a:pPr>
                       <a:r>
                         <a:rPr sz="1425" b="1">
                           <a:solidFill>
@@ -8662,7 +8507,9 @@
                     <a:bodyPr lIns="104775" tIns="57150" rIns="104775" bIns="57150" anchor="ctr"/>
                     <a:lstStyle/>
                     <a:p>
-                      <a:pPr algn="ctr"/>
+                      <a:pPr algn="ctr">
+                        <a:buNone/>
+                      </a:pPr>
                       <a:r>
                         <a:rPr sz="1275" b="0">
                           <a:solidFill>
@@ -8687,7 +8534,9 @@
                     <a:bodyPr lIns="104775" tIns="57150" rIns="104775" bIns="57150" anchor="ctr"/>
                     <a:lstStyle/>
                     <a:p>
-                      <a:pPr algn="ctr"/>
+                      <a:pPr algn="ctr">
+                        <a:buNone/>
+                      </a:pPr>
                       <a:r>
                         <a:rPr sz="1275" b="0">
                           <a:solidFill>
@@ -8712,7 +8561,9 @@
                     <a:bodyPr lIns="104775" tIns="57150" rIns="104775" bIns="57150" anchor="ctr"/>
                     <a:lstStyle/>
                     <a:p>
-                      <a:pPr algn="ctr"/>
+                      <a:pPr algn="ctr">
+                        <a:buNone/>
+                      </a:pPr>
                       <a:r>
                         <a:rPr sz="1275" b="0">
                           <a:solidFill>
@@ -8737,7 +8588,9 @@
                     <a:bodyPr lIns="104775" tIns="57150" rIns="104775" bIns="57150" anchor="ctr"/>
                     <a:lstStyle/>
                     <a:p>
-                      <a:pPr algn="l"/>
+                      <a:pPr algn="l">
+                        <a:buNone/>
+                      </a:pPr>
                       <a:r>
                         <a:rPr sz="1275" b="0">
                           <a:solidFill>
@@ -8797,6 +8650,7 @@
           <a:lstStyle xmlns:a="http://schemas.openxmlformats.org/drawingml/2006/main"/>
           <a:p xmlns:a="http://schemas.openxmlformats.org/drawingml/2006/main">
             <a:pPr algn="l">
+              <a:buNone/>
               <a:defRPr sz="825" b="0" i="0">
                 <a:solidFill>
                   <a:srgbClr val="C07030"/>
@@ -8835,9 +8689,23 @@
   <p:cSld>
     <p:bg>
       <p:bgPr>
-        <a:solidFill xmlns:a="http://schemas.openxmlformats.org/drawingml/2006/main">
-          <a:srgbClr val="232E26"/>
-        </a:solidFill>
+        <a:gradFill xmlns:a="http://schemas.openxmlformats.org/drawingml/2006/main">
+          <a:gsLst>
+            <a:gs pos="0">
+              <a:srgbClr val="232E26"/>
+            </a:gs>
+            <a:gs pos="56000">
+              <a:srgbClr val="232E26"/>
+            </a:gs>
+            <a:gs pos="78000">
+              <a:srgbClr val="2B3026"/>
+            </a:gs>
+            <a:gs pos="100000">
+              <a:srgbClr val="514029"/>
+            </a:gs>
+          </a:gsLst>
+          <a:lin ang="2700000"/>
+        </a:gradFill>
       </p:bgPr>
     </p:bg>
     <p:spTree>
@@ -8851,54 +8719,6 @@
       </p:grpSpPr>
       <p:sp>
         <p:nvSpPr>
-          <p:cNvPr id="1" name="mat-close-wood-glow">
-            <a:extLst xmlns:a="http://schemas.openxmlformats.org/drawingml/2006/main">
-              <a:ext uri="{FF2B5EF4-FFF2-40B4-BE49-F238E27FC236}">
-                <a16:creationId xmlns:a16="http://schemas.microsoft.com/office/drawing/2014/main" id="{B1779D63-530C-4F3D-9768-B41D22667BBC}"/>
-              </a:ext>
-            </a:extLst>
-          </p:cNvPr>
-          <p:cNvSpPr>
-            <a:spLocks xmlns:a="http://schemas.openxmlformats.org/drawingml/2006/main" noGrp="1"/>
-          </p:cNvSpPr>
-          <p:nvPr/>
-        </p:nvSpPr>
-        <p:spPr>
-          <a:xfrm xmlns:a="http://schemas.openxmlformats.org/drawingml/2006/main">
-            <a:off x="7810500" y="3371850"/>
-            <a:ext cx="4324350" cy="3276600"/>
-          </a:xfrm>
-          <a:prstGeom xmlns:a="http://schemas.openxmlformats.org/drawingml/2006/main" prst="ellipse">
-            <a:avLst/>
-          </a:prstGeom>
-          <a:gradFill xmlns:a="http://schemas.openxmlformats.org/drawingml/2006/main">
-            <a:gsLst>
-              <a:gs pos="0">
-                <a:srgbClr val="7A4E24">
-                  <a:alpha val="34000"/>
-                </a:srgbClr>
-              </a:gs>
-              <a:gs pos="46000">
-                <a:srgbClr val="7A4E24">
-                  <a:alpha val="14000"/>
-                </a:srgbClr>
-              </a:gs>
-              <a:gs pos="100000">
-                <a:srgbClr val="232E26">
-                  <a:alpha val="0"/>
-                </a:srgbClr>
-              </a:gs>
-            </a:gsLst>
-            <a:path path="shape"/>
-          </a:gradFill>
-          <a:ln xmlns:a="http://schemas.openxmlformats.org/drawingml/2006/main" w="0">
-            <a:noFill/>
-            <a:prstDash val="solid"/>
-          </a:ln>
-        </p:spPr>
-      </p:sp>
-      <p:sp>
-        <p:nvSpPr>
           <p:cNvPr id="2" name="mat-close-kicker">
             <a:extLst xmlns:a="http://schemas.openxmlformats.org/drawingml/2006/main">
               <a:ext uri="{FF2B5EF4-FFF2-40B4-BE49-F238E27FC236}">
@@ -8932,6 +8752,7 @@
           <a:lstStyle xmlns:a="http://schemas.openxmlformats.org/drawingml/2006/main"/>
           <a:p xmlns:a="http://schemas.openxmlformats.org/drawingml/2006/main">
             <a:pPr algn="l">
+              <a:buNone/>
               <a:defRPr sz="1050" b="0" i="0">
                 <a:solidFill>
                   <a:srgbClr val="C07030"/>
@@ -8990,6 +8811,7 @@
           <a:lstStyle xmlns:a="http://schemas.openxmlformats.org/drawingml/2006/main"/>
           <a:p xmlns:a="http://schemas.openxmlformats.org/drawingml/2006/main">
             <a:pPr algn="l">
+              <a:buNone/>
               <a:defRPr sz="6150" b="1" i="0">
                 <a:solidFill>
                   <a:srgbClr val="F0E8D2"/>
@@ -9048,6 +8870,7 @@
           <a:lstStyle xmlns:a="http://schemas.openxmlformats.org/drawingml/2006/main"/>
           <a:p xmlns:a="http://schemas.openxmlformats.org/drawingml/2006/main">
             <a:pPr algn="l">
+              <a:buNone/>
               <a:defRPr sz="6150" b="1" i="0">
                 <a:solidFill>
                   <a:srgbClr val="C07030"/>
@@ -9137,6 +8960,7 @@
           <a:lstStyle xmlns:a="http://schemas.openxmlformats.org/drawingml/2006/main"/>
           <a:p xmlns:a="http://schemas.openxmlformats.org/drawingml/2006/main">
             <a:pPr algn="l">
+              <a:buNone/>
               <a:defRPr sz="975" b="0" i="0">
                 <a:solidFill>
                   <a:srgbClr val="C07030"/>
@@ -9195,6 +9019,7 @@
           <a:lstStyle xmlns:a="http://schemas.openxmlformats.org/drawingml/2006/main"/>
           <a:p xmlns:a="http://schemas.openxmlformats.org/drawingml/2006/main">
             <a:pPr algn="l">
+              <a:buNone/>
               <a:defRPr sz="1800" b="1" i="0">
                 <a:solidFill>
                   <a:srgbClr val="232E26"/>
@@ -9348,6 +9173,7 @@
           <a:lstStyle xmlns:a="http://schemas.openxmlformats.org/drawingml/2006/main"/>
           <a:p xmlns:a="http://schemas.openxmlformats.org/drawingml/2006/main">
             <a:pPr algn="l">
+              <a:buNone/>
               <a:defRPr sz="975" b="0" i="0">
                 <a:solidFill>
                   <a:srgbClr val="C07030"/>
@@ -9406,6 +9232,7 @@
           <a:lstStyle xmlns:a="http://schemas.openxmlformats.org/drawingml/2006/main"/>
           <a:p xmlns:a="http://schemas.openxmlformats.org/drawingml/2006/main">
             <a:pPr algn="l">
+              <a:buNone/>
               <a:defRPr sz="1800" b="1" i="0">
                 <a:solidFill>
                   <a:srgbClr val="232E26"/>
@@ -9559,6 +9386,7 @@
           <a:lstStyle xmlns:a="http://schemas.openxmlformats.org/drawingml/2006/main"/>
           <a:p xmlns:a="http://schemas.openxmlformats.org/drawingml/2006/main">
             <a:pPr algn="l">
+              <a:buNone/>
               <a:defRPr sz="975" b="0" i="0">
                 <a:solidFill>
                   <a:srgbClr val="C07030"/>
@@ -9617,6 +9445,7 @@
           <a:lstStyle xmlns:a="http://schemas.openxmlformats.org/drawingml/2006/main"/>
           <a:p xmlns:a="http://schemas.openxmlformats.org/drawingml/2006/main">
             <a:pPr algn="l">
+              <a:buNone/>
               <a:defRPr sz="1800" b="1" i="0">
                 <a:solidFill>
                   <a:srgbClr val="232E26"/>
@@ -9737,6 +9566,7 @@
           <a:lstStyle xmlns:a="http://schemas.openxmlformats.org/drawingml/2006/main"/>
           <a:p xmlns:a="http://schemas.openxmlformats.org/drawingml/2006/main">
             <a:pPr algn="l">
+              <a:buNone/>
               <a:defRPr sz="900" b="0" i="0">
                 <a:solidFill>
                   <a:srgbClr val="F0E8D2">

</xml_diff>